<commit_message>
Added remote access instructions to readme. Changed wiring in powerpoint to reflect reversed motor direction
</commit_message>
<xml_diff>
--- a/Wiring Diagram.pptx
+++ b/Wiring Diagram.pptx
@@ -4,8 +4,12 @@
   <p:sldMasterIdLst>
     <p:sldMasterId id="2147483648" r:id="rId1"/>
   </p:sldMasterIdLst>
+  <p:notesMasterIdLst>
+    <p:notesMasterId r:id="rId4"/>
+  </p:notesMasterIdLst>
   <p:sldIdLst>
-    <p:sldId id="256" r:id="rId2"/>
+    <p:sldId id="257" r:id="rId2"/>
+    <p:sldId id="256" r:id="rId3"/>
   </p:sldIdLst>
   <p:sldSz cx="12192000" cy="6858000"/>
   <p:notesSz cx="6858000" cy="9144000"/>
@@ -112,6 +116,531 @@
 </p:presentation>
 </file>
 
+<file path=ppt/notesMasters/notesMaster1.xml><?xml version="1.0" encoding="utf-8"?>
+<p:notesMaster xmlns:a="http://schemas.openxmlformats.org/drawingml/2006/main" xmlns:r="http://schemas.openxmlformats.org/officeDocument/2006/relationships" xmlns:p="http://schemas.openxmlformats.org/presentationml/2006/main">
+  <p:cSld>
+    <p:bg>
+      <p:bgRef idx="1001">
+        <a:schemeClr val="bg1"/>
+      </p:bgRef>
+    </p:bg>
+    <p:spTree>
+      <p:nvGrpSpPr>
+        <p:cNvPr id="1" name=""/>
+        <p:cNvGrpSpPr/>
+        <p:nvPr/>
+      </p:nvGrpSpPr>
+      <p:grpSpPr>
+        <a:xfrm>
+          <a:off x="0" y="0"/>
+          <a:ext cx="0" cy="0"/>
+          <a:chOff x="0" y="0"/>
+          <a:chExt cx="0" cy="0"/>
+        </a:xfrm>
+      </p:grpSpPr>
+      <p:sp>
+        <p:nvSpPr>
+          <p:cNvPr id="2" name="Header Placeholder 1"/>
+          <p:cNvSpPr>
+            <a:spLocks noGrp="1"/>
+          </p:cNvSpPr>
+          <p:nvPr>
+            <p:ph type="hdr" sz="quarter"/>
+          </p:nvPr>
+        </p:nvSpPr>
+        <p:spPr>
+          <a:xfrm>
+            <a:off x="0" y="0"/>
+            <a:ext cx="2971800" cy="458788"/>
+          </a:xfrm>
+          <a:prstGeom prst="rect">
+            <a:avLst/>
+          </a:prstGeom>
+        </p:spPr>
+        <p:txBody>
+          <a:bodyPr vert="horz" lIns="91440" tIns="45720" rIns="91440" bIns="45720" rtlCol="0"/>
+          <a:lstStyle>
+            <a:lvl1pPr algn="l">
+              <a:defRPr sz="1200"/>
+            </a:lvl1pPr>
+          </a:lstStyle>
+          <a:p>
+            <a:endParaRPr lang="en-US"/>
+          </a:p>
+        </p:txBody>
+      </p:sp>
+      <p:sp>
+        <p:nvSpPr>
+          <p:cNvPr id="3" name="Date Placeholder 2"/>
+          <p:cNvSpPr>
+            <a:spLocks noGrp="1"/>
+          </p:cNvSpPr>
+          <p:nvPr>
+            <p:ph type="dt" idx="1"/>
+          </p:nvPr>
+        </p:nvSpPr>
+        <p:spPr>
+          <a:xfrm>
+            <a:off x="3884613" y="0"/>
+            <a:ext cx="2971800" cy="458788"/>
+          </a:xfrm>
+          <a:prstGeom prst="rect">
+            <a:avLst/>
+          </a:prstGeom>
+        </p:spPr>
+        <p:txBody>
+          <a:bodyPr vert="horz" lIns="91440" tIns="45720" rIns="91440" bIns="45720" rtlCol="0"/>
+          <a:lstStyle>
+            <a:lvl1pPr algn="r">
+              <a:defRPr sz="1200"/>
+            </a:lvl1pPr>
+          </a:lstStyle>
+          <a:p>
+            <a:fld id="{52BA6CF6-DCE0-4316-98B8-E757110DEC71}" type="datetimeFigureOut">
+              <a:rPr lang="en-US" smtClean="0"/>
+              <a:t>3/13/2026</a:t>
+            </a:fld>
+            <a:endParaRPr lang="en-US"/>
+          </a:p>
+        </p:txBody>
+      </p:sp>
+      <p:sp>
+        <p:nvSpPr>
+          <p:cNvPr id="4" name="Slide Image Placeholder 3"/>
+          <p:cNvSpPr>
+            <a:spLocks noGrp="1" noRot="1" noChangeAspect="1"/>
+          </p:cNvSpPr>
+          <p:nvPr>
+            <p:ph type="sldImg" idx="2"/>
+          </p:nvPr>
+        </p:nvSpPr>
+        <p:spPr>
+          <a:xfrm>
+            <a:off x="685800" y="1143000"/>
+            <a:ext cx="5486400" cy="3086100"/>
+          </a:xfrm>
+          <a:prstGeom prst="rect">
+            <a:avLst/>
+          </a:prstGeom>
+          <a:noFill/>
+          <a:ln w="12700">
+            <a:solidFill>
+              <a:prstClr val="black"/>
+            </a:solidFill>
+          </a:ln>
+        </p:spPr>
+        <p:txBody>
+          <a:bodyPr vert="horz" lIns="91440" tIns="45720" rIns="91440" bIns="45720" rtlCol="0" anchor="ctr"/>
+          <a:lstStyle/>
+          <a:p>
+            <a:endParaRPr lang="en-US"/>
+          </a:p>
+        </p:txBody>
+      </p:sp>
+      <p:sp>
+        <p:nvSpPr>
+          <p:cNvPr id="5" name="Notes Placeholder 4"/>
+          <p:cNvSpPr>
+            <a:spLocks noGrp="1"/>
+          </p:cNvSpPr>
+          <p:nvPr>
+            <p:ph type="body" sz="quarter" idx="3"/>
+          </p:nvPr>
+        </p:nvSpPr>
+        <p:spPr>
+          <a:xfrm>
+            <a:off x="685800" y="4400550"/>
+            <a:ext cx="5486400" cy="3600450"/>
+          </a:xfrm>
+          <a:prstGeom prst="rect">
+            <a:avLst/>
+          </a:prstGeom>
+        </p:spPr>
+        <p:txBody>
+          <a:bodyPr vert="horz" lIns="91440" tIns="45720" rIns="91440" bIns="45720" rtlCol="0"/>
+          <a:lstStyle/>
+          <a:p>
+            <a:pPr lvl="0"/>
+            <a:r>
+              <a:rPr lang="en-US"/>
+              <a:t>Click to edit Master text styles</a:t>
+            </a:r>
+          </a:p>
+          <a:p>
+            <a:pPr lvl="1"/>
+            <a:r>
+              <a:rPr lang="en-US"/>
+              <a:t>Second level</a:t>
+            </a:r>
+          </a:p>
+          <a:p>
+            <a:pPr lvl="2"/>
+            <a:r>
+              <a:rPr lang="en-US"/>
+              <a:t>Third level</a:t>
+            </a:r>
+          </a:p>
+          <a:p>
+            <a:pPr lvl="3"/>
+            <a:r>
+              <a:rPr lang="en-US"/>
+              <a:t>Fourth level</a:t>
+            </a:r>
+          </a:p>
+          <a:p>
+            <a:pPr lvl="4"/>
+            <a:r>
+              <a:rPr lang="en-US"/>
+              <a:t>Fifth level</a:t>
+            </a:r>
+          </a:p>
+        </p:txBody>
+      </p:sp>
+      <p:sp>
+        <p:nvSpPr>
+          <p:cNvPr id="6" name="Footer Placeholder 5"/>
+          <p:cNvSpPr>
+            <a:spLocks noGrp="1"/>
+          </p:cNvSpPr>
+          <p:nvPr>
+            <p:ph type="ftr" sz="quarter" idx="4"/>
+          </p:nvPr>
+        </p:nvSpPr>
+        <p:spPr>
+          <a:xfrm>
+            <a:off x="0" y="8685213"/>
+            <a:ext cx="2971800" cy="458787"/>
+          </a:xfrm>
+          <a:prstGeom prst="rect">
+            <a:avLst/>
+          </a:prstGeom>
+        </p:spPr>
+        <p:txBody>
+          <a:bodyPr vert="horz" lIns="91440" tIns="45720" rIns="91440" bIns="45720" rtlCol="0" anchor="b"/>
+          <a:lstStyle>
+            <a:lvl1pPr algn="l">
+              <a:defRPr sz="1200"/>
+            </a:lvl1pPr>
+          </a:lstStyle>
+          <a:p>
+            <a:endParaRPr lang="en-US"/>
+          </a:p>
+        </p:txBody>
+      </p:sp>
+      <p:sp>
+        <p:nvSpPr>
+          <p:cNvPr id="7" name="Slide Number Placeholder 6"/>
+          <p:cNvSpPr>
+            <a:spLocks noGrp="1"/>
+          </p:cNvSpPr>
+          <p:nvPr>
+            <p:ph type="sldNum" sz="quarter" idx="5"/>
+          </p:nvPr>
+        </p:nvSpPr>
+        <p:spPr>
+          <a:xfrm>
+            <a:off x="3884613" y="8685213"/>
+            <a:ext cx="2971800" cy="458787"/>
+          </a:xfrm>
+          <a:prstGeom prst="rect">
+            <a:avLst/>
+          </a:prstGeom>
+        </p:spPr>
+        <p:txBody>
+          <a:bodyPr vert="horz" lIns="91440" tIns="45720" rIns="91440" bIns="45720" rtlCol="0" anchor="b"/>
+          <a:lstStyle>
+            <a:lvl1pPr algn="r">
+              <a:defRPr sz="1200"/>
+            </a:lvl1pPr>
+          </a:lstStyle>
+          <a:p>
+            <a:fld id="{C53D2868-0A52-456C-9A58-13685B27E94B}" type="slidenum">
+              <a:rPr lang="en-US" smtClean="0"/>
+              <a:t>‹#›</a:t>
+            </a:fld>
+            <a:endParaRPr lang="en-US"/>
+          </a:p>
+        </p:txBody>
+      </p:sp>
+    </p:spTree>
+    <p:extLst>
+      <p:ext uri="{BB962C8B-B14F-4D97-AF65-F5344CB8AC3E}">
+        <p14:creationId xmlns:p14="http://schemas.microsoft.com/office/powerpoint/2010/main" val="1185305516"/>
+      </p:ext>
+    </p:extLst>
+  </p:cSld>
+  <p:clrMap bg1="lt1" tx1="dk1" bg2="lt2" tx2="dk2" accent1="accent1" accent2="accent2" accent3="accent3" accent4="accent4" accent5="accent5" accent6="accent6" hlink="hlink" folHlink="folHlink"/>
+  <p:notesStyle>
+    <a:lvl1pPr marL="0" algn="l" defTabSz="914400" rtl="0" eaLnBrk="1" latinLnBrk="0" hangingPunct="1">
+      <a:defRPr sz="1200" kern="1200">
+        <a:solidFill>
+          <a:schemeClr val="tx1"/>
+        </a:solidFill>
+        <a:latin typeface="+mn-lt"/>
+        <a:ea typeface="+mn-ea"/>
+        <a:cs typeface="+mn-cs"/>
+      </a:defRPr>
+    </a:lvl1pPr>
+    <a:lvl2pPr marL="457200" algn="l" defTabSz="914400" rtl="0" eaLnBrk="1" latinLnBrk="0" hangingPunct="1">
+      <a:defRPr sz="1200" kern="1200">
+        <a:solidFill>
+          <a:schemeClr val="tx1"/>
+        </a:solidFill>
+        <a:latin typeface="+mn-lt"/>
+        <a:ea typeface="+mn-ea"/>
+        <a:cs typeface="+mn-cs"/>
+      </a:defRPr>
+    </a:lvl2pPr>
+    <a:lvl3pPr marL="914400" algn="l" defTabSz="914400" rtl="0" eaLnBrk="1" latinLnBrk="0" hangingPunct="1">
+      <a:defRPr sz="1200" kern="1200">
+        <a:solidFill>
+          <a:schemeClr val="tx1"/>
+        </a:solidFill>
+        <a:latin typeface="+mn-lt"/>
+        <a:ea typeface="+mn-ea"/>
+        <a:cs typeface="+mn-cs"/>
+      </a:defRPr>
+    </a:lvl3pPr>
+    <a:lvl4pPr marL="1371600" algn="l" defTabSz="914400" rtl="0" eaLnBrk="1" latinLnBrk="0" hangingPunct="1">
+      <a:defRPr sz="1200" kern="1200">
+        <a:solidFill>
+          <a:schemeClr val="tx1"/>
+        </a:solidFill>
+        <a:latin typeface="+mn-lt"/>
+        <a:ea typeface="+mn-ea"/>
+        <a:cs typeface="+mn-cs"/>
+      </a:defRPr>
+    </a:lvl4pPr>
+    <a:lvl5pPr marL="1828800" algn="l" defTabSz="914400" rtl="0" eaLnBrk="1" latinLnBrk="0" hangingPunct="1">
+      <a:defRPr sz="1200" kern="1200">
+        <a:solidFill>
+          <a:schemeClr val="tx1"/>
+        </a:solidFill>
+        <a:latin typeface="+mn-lt"/>
+        <a:ea typeface="+mn-ea"/>
+        <a:cs typeface="+mn-cs"/>
+      </a:defRPr>
+    </a:lvl5pPr>
+    <a:lvl6pPr marL="2286000" algn="l" defTabSz="914400" rtl="0" eaLnBrk="1" latinLnBrk="0" hangingPunct="1">
+      <a:defRPr sz="1200" kern="1200">
+        <a:solidFill>
+          <a:schemeClr val="tx1"/>
+        </a:solidFill>
+        <a:latin typeface="+mn-lt"/>
+        <a:ea typeface="+mn-ea"/>
+        <a:cs typeface="+mn-cs"/>
+      </a:defRPr>
+    </a:lvl6pPr>
+    <a:lvl7pPr marL="2743200" algn="l" defTabSz="914400" rtl="0" eaLnBrk="1" latinLnBrk="0" hangingPunct="1">
+      <a:defRPr sz="1200" kern="1200">
+        <a:solidFill>
+          <a:schemeClr val="tx1"/>
+        </a:solidFill>
+        <a:latin typeface="+mn-lt"/>
+        <a:ea typeface="+mn-ea"/>
+        <a:cs typeface="+mn-cs"/>
+      </a:defRPr>
+    </a:lvl7pPr>
+    <a:lvl8pPr marL="3200400" algn="l" defTabSz="914400" rtl="0" eaLnBrk="1" latinLnBrk="0" hangingPunct="1">
+      <a:defRPr sz="1200" kern="1200">
+        <a:solidFill>
+          <a:schemeClr val="tx1"/>
+        </a:solidFill>
+        <a:latin typeface="+mn-lt"/>
+        <a:ea typeface="+mn-ea"/>
+        <a:cs typeface="+mn-cs"/>
+      </a:defRPr>
+    </a:lvl8pPr>
+    <a:lvl9pPr marL="3657600" algn="l" defTabSz="914400" rtl="0" eaLnBrk="1" latinLnBrk="0" hangingPunct="1">
+      <a:defRPr sz="1200" kern="1200">
+        <a:solidFill>
+          <a:schemeClr val="tx1"/>
+        </a:solidFill>
+        <a:latin typeface="+mn-lt"/>
+        <a:ea typeface="+mn-ea"/>
+        <a:cs typeface="+mn-cs"/>
+      </a:defRPr>
+    </a:lvl9pPr>
+  </p:notesStyle>
+</p:notesMaster>
+</file>
+
+<file path=ppt/notesSlides/notesSlide1.xml><?xml version="1.0" encoding="utf-8"?>
+<p:notes xmlns:a="http://schemas.openxmlformats.org/drawingml/2006/main" xmlns:r="http://schemas.openxmlformats.org/officeDocument/2006/relationships" xmlns:p="http://schemas.openxmlformats.org/presentationml/2006/main">
+  <p:cSld>
+    <p:spTree>
+      <p:nvGrpSpPr>
+        <p:cNvPr id="1" name=""/>
+        <p:cNvGrpSpPr/>
+        <p:nvPr/>
+      </p:nvGrpSpPr>
+      <p:grpSpPr>
+        <a:xfrm>
+          <a:off x="0" y="0"/>
+          <a:ext cx="0" cy="0"/>
+          <a:chOff x="0" y="0"/>
+          <a:chExt cx="0" cy="0"/>
+        </a:xfrm>
+      </p:grpSpPr>
+      <p:sp>
+        <p:nvSpPr>
+          <p:cNvPr id="2" name="Slide Image Placeholder 1"/>
+          <p:cNvSpPr>
+            <a:spLocks noGrp="1" noRot="1" noChangeAspect="1"/>
+          </p:cNvSpPr>
+          <p:nvPr>
+            <p:ph type="sldImg"/>
+          </p:nvPr>
+        </p:nvSpPr>
+        <p:spPr/>
+      </p:sp>
+      <p:sp>
+        <p:nvSpPr>
+          <p:cNvPr id="3" name="Notes Placeholder 2"/>
+          <p:cNvSpPr>
+            <a:spLocks noGrp="1"/>
+          </p:cNvSpPr>
+          <p:nvPr>
+            <p:ph type="body" idx="1"/>
+          </p:nvPr>
+        </p:nvSpPr>
+        <p:spPr/>
+        <p:txBody>
+          <a:bodyPr/>
+          <a:lstStyle/>
+          <a:p>
+            <a:r>
+              <a:rPr lang="tl-001" dirty="0"/>
+              <a:t>This one is good for the stemulate santa ana workshop 3/13/26 (only difference is the switched pairs of wires that control motor direction)</a:t>
+            </a:r>
+            <a:endParaRPr lang="en-US" dirty="0"/>
+          </a:p>
+        </p:txBody>
+      </p:sp>
+      <p:sp>
+        <p:nvSpPr>
+          <p:cNvPr id="4" name="Slide Number Placeholder 3"/>
+          <p:cNvSpPr>
+            <a:spLocks noGrp="1"/>
+          </p:cNvSpPr>
+          <p:nvPr>
+            <p:ph type="sldNum" sz="quarter" idx="5"/>
+          </p:nvPr>
+        </p:nvSpPr>
+        <p:spPr/>
+        <p:txBody>
+          <a:bodyPr/>
+          <a:lstStyle/>
+          <a:p>
+            <a:fld id="{C53D2868-0A52-456C-9A58-13685B27E94B}" type="slidenum">
+              <a:rPr lang="en-US" smtClean="0"/>
+              <a:t>1</a:t>
+            </a:fld>
+            <a:endParaRPr lang="en-US"/>
+          </a:p>
+        </p:txBody>
+      </p:sp>
+    </p:spTree>
+    <p:extLst>
+      <p:ext uri="{BB962C8B-B14F-4D97-AF65-F5344CB8AC3E}">
+        <p14:creationId xmlns:p14="http://schemas.microsoft.com/office/powerpoint/2010/main" val="1040297906"/>
+      </p:ext>
+    </p:extLst>
+  </p:cSld>
+  <p:clrMapOvr>
+    <a:masterClrMapping/>
+  </p:clrMapOvr>
+</p:notes>
+</file>
+
+<file path=ppt/notesSlides/notesSlide2.xml><?xml version="1.0" encoding="utf-8"?>
+<p:notes xmlns:a="http://schemas.openxmlformats.org/drawingml/2006/main" xmlns:r="http://schemas.openxmlformats.org/officeDocument/2006/relationships" xmlns:p="http://schemas.openxmlformats.org/presentationml/2006/main">
+  <p:cSld>
+    <p:spTree>
+      <p:nvGrpSpPr>
+        <p:cNvPr id="1" name=""/>
+        <p:cNvGrpSpPr/>
+        <p:nvPr/>
+      </p:nvGrpSpPr>
+      <p:grpSpPr>
+        <a:xfrm>
+          <a:off x="0" y="0"/>
+          <a:ext cx="0" cy="0"/>
+          <a:chOff x="0" y="0"/>
+          <a:chExt cx="0" cy="0"/>
+        </a:xfrm>
+      </p:grpSpPr>
+      <p:sp>
+        <p:nvSpPr>
+          <p:cNvPr id="2" name="Slide Image Placeholder 1"/>
+          <p:cNvSpPr>
+            <a:spLocks noGrp="1" noRot="1" noChangeAspect="1"/>
+          </p:cNvSpPr>
+          <p:nvPr>
+            <p:ph type="sldImg"/>
+          </p:nvPr>
+        </p:nvSpPr>
+        <p:spPr/>
+      </p:sp>
+      <p:sp>
+        <p:nvSpPr>
+          <p:cNvPr id="3" name="Notes Placeholder 2"/>
+          <p:cNvSpPr>
+            <a:spLocks noGrp="1"/>
+          </p:cNvSpPr>
+          <p:nvPr>
+            <p:ph type="body" idx="1"/>
+          </p:nvPr>
+        </p:nvSpPr>
+        <p:spPr/>
+        <p:txBody>
+          <a:bodyPr/>
+          <a:lstStyle/>
+          <a:p>
+            <a:r>
+              <a:rPr lang="tl-001"/>
+              <a:t>Original 2025 Summer Robotics Camp Design</a:t>
+            </a:r>
+            <a:endParaRPr lang="en-US"/>
+          </a:p>
+        </p:txBody>
+      </p:sp>
+      <p:sp>
+        <p:nvSpPr>
+          <p:cNvPr id="4" name="Slide Number Placeholder 3"/>
+          <p:cNvSpPr>
+            <a:spLocks noGrp="1"/>
+          </p:cNvSpPr>
+          <p:nvPr>
+            <p:ph type="sldNum" sz="quarter" idx="5"/>
+          </p:nvPr>
+        </p:nvSpPr>
+        <p:spPr/>
+        <p:txBody>
+          <a:bodyPr/>
+          <a:lstStyle/>
+          <a:p>
+            <a:fld id="{C53D2868-0A52-456C-9A58-13685B27E94B}" type="slidenum">
+              <a:rPr lang="en-US" smtClean="0"/>
+              <a:t>2</a:t>
+            </a:fld>
+            <a:endParaRPr lang="en-US"/>
+          </a:p>
+        </p:txBody>
+      </p:sp>
+    </p:spTree>
+    <p:extLst>
+      <p:ext uri="{BB962C8B-B14F-4D97-AF65-F5344CB8AC3E}">
+        <p14:creationId xmlns:p14="http://schemas.microsoft.com/office/powerpoint/2010/main" val="1178422513"/>
+      </p:ext>
+    </p:extLst>
+  </p:cSld>
+  <p:clrMapOvr>
+    <a:masterClrMapping/>
+  </p:clrMapOvr>
+</p:notes>
+</file>
+
 <file path=ppt/slideLayouts/slideLayout1.xml><?xml version="1.0" encoding="utf-8"?>
 <p:sldLayout xmlns:a="http://schemas.openxmlformats.org/drawingml/2006/main" xmlns:r="http://schemas.openxmlformats.org/officeDocument/2006/relationships" xmlns:p="http://schemas.openxmlformats.org/presentationml/2006/main" type="title" preserve="1">
   <p:cSld name="Slide ng Pamagat">
@@ -261,7 +790,7 @@
           <a:p>
             <a:fld id="{B47660E7-750B-49BC-BBA0-1555F4D53996}" type="datetimeFigureOut">
               <a:rPr lang="en-US" smtClean="0"/>
-              <a:t>8/7/2025</a:t>
+              <a:t>3/13/2026</a:t>
             </a:fld>
             <a:endParaRPr lang="en-US"/>
           </a:p>
@@ -461,7 +990,7 @@
           <a:p>
             <a:fld id="{B47660E7-750B-49BC-BBA0-1555F4D53996}" type="datetimeFigureOut">
               <a:rPr lang="en-US" smtClean="0"/>
-              <a:t>8/7/2025</a:t>
+              <a:t>3/13/2026</a:t>
             </a:fld>
             <a:endParaRPr lang="en-US"/>
           </a:p>
@@ -671,7 +1200,7 @@
           <a:p>
             <a:fld id="{B47660E7-750B-49BC-BBA0-1555F4D53996}" type="datetimeFigureOut">
               <a:rPr lang="en-US" smtClean="0"/>
-              <a:t>8/7/2025</a:t>
+              <a:t>3/13/2026</a:t>
             </a:fld>
             <a:endParaRPr lang="en-US"/>
           </a:p>
@@ -871,7 +1400,7 @@
           <a:p>
             <a:fld id="{B47660E7-750B-49BC-BBA0-1555F4D53996}" type="datetimeFigureOut">
               <a:rPr lang="en-US" smtClean="0"/>
-              <a:t>8/7/2025</a:t>
+              <a:t>3/13/2026</a:t>
             </a:fld>
             <a:endParaRPr lang="en-US"/>
           </a:p>
@@ -1147,7 +1676,7 @@
           <a:p>
             <a:fld id="{B47660E7-750B-49BC-BBA0-1555F4D53996}" type="datetimeFigureOut">
               <a:rPr lang="en-US" smtClean="0"/>
-              <a:t>8/7/2025</a:t>
+              <a:t>3/13/2026</a:t>
             </a:fld>
             <a:endParaRPr lang="en-US"/>
           </a:p>
@@ -1415,7 +1944,7 @@
           <a:p>
             <a:fld id="{B47660E7-750B-49BC-BBA0-1555F4D53996}" type="datetimeFigureOut">
               <a:rPr lang="en-US" smtClean="0"/>
-              <a:t>8/7/2025</a:t>
+              <a:t>3/13/2026</a:t>
             </a:fld>
             <a:endParaRPr lang="en-US"/>
           </a:p>
@@ -1830,7 +2359,7 @@
           <a:p>
             <a:fld id="{B47660E7-750B-49BC-BBA0-1555F4D53996}" type="datetimeFigureOut">
               <a:rPr lang="en-US" smtClean="0"/>
-              <a:t>8/7/2025</a:t>
+              <a:t>3/13/2026</a:t>
             </a:fld>
             <a:endParaRPr lang="en-US"/>
           </a:p>
@@ -1972,7 +2501,7 @@
           <a:p>
             <a:fld id="{B47660E7-750B-49BC-BBA0-1555F4D53996}" type="datetimeFigureOut">
               <a:rPr lang="en-US" smtClean="0"/>
-              <a:t>8/7/2025</a:t>
+              <a:t>3/13/2026</a:t>
             </a:fld>
             <a:endParaRPr lang="en-US"/>
           </a:p>
@@ -2085,7 +2614,7 @@
           <a:p>
             <a:fld id="{B47660E7-750B-49BC-BBA0-1555F4D53996}" type="datetimeFigureOut">
               <a:rPr lang="en-US" smtClean="0"/>
-              <a:t>8/7/2025</a:t>
+              <a:t>3/13/2026</a:t>
             </a:fld>
             <a:endParaRPr lang="en-US"/>
           </a:p>
@@ -2398,7 +2927,7 @@
           <a:p>
             <a:fld id="{B47660E7-750B-49BC-BBA0-1555F4D53996}" type="datetimeFigureOut">
               <a:rPr lang="en-US" smtClean="0"/>
-              <a:t>8/7/2025</a:t>
+              <a:t>3/13/2026</a:t>
             </a:fld>
             <a:endParaRPr lang="en-US"/>
           </a:p>
@@ -2687,7 +3216,7 @@
           <a:p>
             <a:fld id="{B47660E7-750B-49BC-BBA0-1555F4D53996}" type="datetimeFigureOut">
               <a:rPr lang="en-US" smtClean="0"/>
-              <a:t>8/7/2025</a:t>
+              <a:t>3/13/2026</a:t>
             </a:fld>
             <a:endParaRPr lang="en-US"/>
           </a:p>
@@ -2930,7 +3459,7 @@
           <a:p>
             <a:fld id="{B47660E7-750B-49BC-BBA0-1555F4D53996}" type="datetimeFigureOut">
               <a:rPr lang="en-US" smtClean="0"/>
-              <a:t>8/7/2025</a:t>
+              <a:t>3/13/2026</a:t>
             </a:fld>
             <a:endParaRPr lang="en-US"/>
           </a:p>
@@ -3335,6 +3864,1496 @@
   <p:cSld>
     <p:spTree>
       <p:nvGrpSpPr>
+        <p:cNvPr id="1" name="">
+          <a:extLst>
+            <a:ext uri="{FF2B5EF4-FFF2-40B4-BE49-F238E27FC236}">
+              <a16:creationId xmlns:a16="http://schemas.microsoft.com/office/drawing/2014/main" id="{E1A2E38B-52F3-A807-41FD-E083F83D79BD}"/>
+            </a:ext>
+          </a:extLst>
+        </p:cNvPr>
+        <p:cNvGrpSpPr/>
+        <p:nvPr/>
+      </p:nvGrpSpPr>
+      <p:grpSpPr>
+        <a:xfrm>
+          <a:off x="0" y="0"/>
+          <a:ext cx="0" cy="0"/>
+          <a:chOff x="0" y="0"/>
+          <a:chExt cx="0" cy="0"/>
+        </a:xfrm>
+      </p:grpSpPr>
+      <p:pic>
+        <p:nvPicPr>
+          <p:cNvPr id="5" name="Larawan 4">
+            <a:extLst>
+              <a:ext uri="{FF2B5EF4-FFF2-40B4-BE49-F238E27FC236}">
+                <a16:creationId xmlns:a16="http://schemas.microsoft.com/office/drawing/2014/main" id="{36188757-CF85-892C-63BD-FBB099C02F05}"/>
+              </a:ext>
+            </a:extLst>
+          </p:cNvPr>
+          <p:cNvPicPr>
+            <a:picLocks noChangeAspect="1"/>
+          </p:cNvPicPr>
+          <p:nvPr/>
+        </p:nvPicPr>
+        <p:blipFill>
+          <a:blip r:embed="rId3"/>
+          <a:stretch>
+            <a:fillRect/>
+          </a:stretch>
+        </p:blipFill>
+        <p:spPr>
+          <a:xfrm rot="10800000">
+            <a:off x="-23594" y="2006505"/>
+            <a:ext cx="3686689" cy="1762371"/>
+          </a:xfrm>
+          <a:prstGeom prst="rect">
+            <a:avLst/>
+          </a:prstGeom>
+        </p:spPr>
+      </p:pic>
+      <p:pic>
+        <p:nvPicPr>
+          <p:cNvPr id="7" name="Larawan 6">
+            <a:extLst>
+              <a:ext uri="{FF2B5EF4-FFF2-40B4-BE49-F238E27FC236}">
+                <a16:creationId xmlns:a16="http://schemas.microsoft.com/office/drawing/2014/main" id="{59C5D6B3-3751-63DC-2A6B-8F505FFB5035}"/>
+              </a:ext>
+            </a:extLst>
+          </p:cNvPr>
+          <p:cNvPicPr>
+            <a:picLocks noChangeAspect="1"/>
+          </p:cNvPicPr>
+          <p:nvPr/>
+        </p:nvPicPr>
+        <p:blipFill>
+          <a:blip r:embed="rId3"/>
+          <a:stretch>
+            <a:fillRect/>
+          </a:stretch>
+        </p:blipFill>
+        <p:spPr>
+          <a:xfrm>
+            <a:off x="7280666" y="1876558"/>
+            <a:ext cx="3686689" cy="1762371"/>
+          </a:xfrm>
+          <a:prstGeom prst="rect">
+            <a:avLst/>
+          </a:prstGeom>
+        </p:spPr>
+      </p:pic>
+      <p:pic>
+        <p:nvPicPr>
+          <p:cNvPr id="11" name="Larawan 10">
+            <a:extLst>
+              <a:ext uri="{FF2B5EF4-FFF2-40B4-BE49-F238E27FC236}">
+                <a16:creationId xmlns:a16="http://schemas.microsoft.com/office/drawing/2014/main" id="{D50D7667-C427-52BB-C475-8C1EBDD9C5A7}"/>
+              </a:ext>
+            </a:extLst>
+          </p:cNvPr>
+          <p:cNvPicPr>
+            <a:picLocks noChangeAspect="1"/>
+          </p:cNvPicPr>
+          <p:nvPr/>
+        </p:nvPicPr>
+        <p:blipFill>
+          <a:blip r:embed="rId4"/>
+          <a:stretch>
+            <a:fillRect/>
+          </a:stretch>
+        </p:blipFill>
+        <p:spPr>
+          <a:xfrm rot="10800000">
+            <a:off x="6744428" y="2975238"/>
+            <a:ext cx="5163271" cy="3553321"/>
+          </a:xfrm>
+          <a:prstGeom prst="rect">
+            <a:avLst/>
+          </a:prstGeom>
+        </p:spPr>
+      </p:pic>
+      <p:pic>
+        <p:nvPicPr>
+          <p:cNvPr id="13" name="Larawan 12">
+            <a:extLst>
+              <a:ext uri="{FF2B5EF4-FFF2-40B4-BE49-F238E27FC236}">
+                <a16:creationId xmlns:a16="http://schemas.microsoft.com/office/drawing/2014/main" id="{C286B20C-9987-28AD-1E13-2FC067380F8D}"/>
+              </a:ext>
+            </a:extLst>
+          </p:cNvPr>
+          <p:cNvPicPr>
+            <a:picLocks noChangeAspect="1"/>
+          </p:cNvPicPr>
+          <p:nvPr/>
+        </p:nvPicPr>
+        <p:blipFill>
+          <a:blip r:embed="rId5"/>
+          <a:stretch>
+            <a:fillRect/>
+          </a:stretch>
+        </p:blipFill>
+        <p:spPr>
+          <a:xfrm rot="5400000">
+            <a:off x="808693" y="4042631"/>
+            <a:ext cx="1971950" cy="2962688"/>
+          </a:xfrm>
+          <a:prstGeom prst="rect">
+            <a:avLst/>
+          </a:prstGeom>
+        </p:spPr>
+      </p:pic>
+      <p:cxnSp>
+        <p:nvCxnSpPr>
+          <p:cNvPr id="23" name="Tuwid na Konektor 22">
+            <a:extLst>
+              <a:ext uri="{FF2B5EF4-FFF2-40B4-BE49-F238E27FC236}">
+                <a16:creationId xmlns:a16="http://schemas.microsoft.com/office/drawing/2014/main" id="{C79C64F3-1193-95AC-D17B-1107BC16171A}"/>
+              </a:ext>
+            </a:extLst>
+          </p:cNvPr>
+          <p:cNvCxnSpPr>
+            <a:cxnSpLocks/>
+          </p:cNvCxnSpPr>
+          <p:nvPr/>
+        </p:nvCxnSpPr>
+        <p:spPr>
+          <a:xfrm>
+            <a:off x="2999949" y="6419122"/>
+            <a:ext cx="1846799" cy="10965"/>
+          </a:xfrm>
+          <a:prstGeom prst="line">
+            <a:avLst/>
+          </a:prstGeom>
+          <a:ln w="76200">
+            <a:solidFill>
+              <a:schemeClr val="accent2"/>
+            </a:solidFill>
+          </a:ln>
+        </p:spPr>
+        <p:style>
+          <a:lnRef idx="2">
+            <a:schemeClr val="accent1"/>
+          </a:lnRef>
+          <a:fillRef idx="0">
+            <a:schemeClr val="accent1"/>
+          </a:fillRef>
+          <a:effectRef idx="1">
+            <a:schemeClr val="accent1"/>
+          </a:effectRef>
+          <a:fontRef idx="minor">
+            <a:schemeClr val="tx1"/>
+          </a:fontRef>
+        </p:style>
+      </p:cxnSp>
+      <p:cxnSp>
+        <p:nvCxnSpPr>
+          <p:cNvPr id="24" name="Tuwid na Konektor 23">
+            <a:extLst>
+              <a:ext uri="{FF2B5EF4-FFF2-40B4-BE49-F238E27FC236}">
+                <a16:creationId xmlns:a16="http://schemas.microsoft.com/office/drawing/2014/main" id="{6E690050-CB53-2142-2C3E-C0926CAE4B2E}"/>
+              </a:ext>
+            </a:extLst>
+          </p:cNvPr>
+          <p:cNvCxnSpPr>
+            <a:cxnSpLocks/>
+          </p:cNvCxnSpPr>
+          <p:nvPr/>
+        </p:nvCxnSpPr>
+        <p:spPr>
+          <a:xfrm flipV="1">
+            <a:off x="4693692" y="3768877"/>
+            <a:ext cx="0" cy="2650245"/>
+          </a:xfrm>
+          <a:prstGeom prst="line">
+            <a:avLst/>
+          </a:prstGeom>
+          <a:ln w="76200">
+            <a:solidFill>
+              <a:schemeClr val="accent2"/>
+            </a:solidFill>
+          </a:ln>
+        </p:spPr>
+        <p:style>
+          <a:lnRef idx="2">
+            <a:schemeClr val="accent1"/>
+          </a:lnRef>
+          <a:fillRef idx="0">
+            <a:schemeClr val="accent1"/>
+          </a:fillRef>
+          <a:effectRef idx="1">
+            <a:schemeClr val="accent1"/>
+          </a:effectRef>
+          <a:fontRef idx="minor">
+            <a:schemeClr val="tx1"/>
+          </a:fontRef>
+        </p:style>
+      </p:cxnSp>
+      <p:cxnSp>
+        <p:nvCxnSpPr>
+          <p:cNvPr id="28" name="Tuwid na Konektor 27">
+            <a:extLst>
+              <a:ext uri="{FF2B5EF4-FFF2-40B4-BE49-F238E27FC236}">
+                <a16:creationId xmlns:a16="http://schemas.microsoft.com/office/drawing/2014/main" id="{EAB27C4A-A4F2-192F-EE75-E728796079B8}"/>
+              </a:ext>
+            </a:extLst>
+          </p:cNvPr>
+          <p:cNvCxnSpPr>
+            <a:cxnSpLocks/>
+          </p:cNvCxnSpPr>
+          <p:nvPr/>
+        </p:nvCxnSpPr>
+        <p:spPr>
+          <a:xfrm>
+            <a:off x="2882900" y="6647722"/>
+            <a:ext cx="2098533" cy="0"/>
+          </a:xfrm>
+          <a:prstGeom prst="line">
+            <a:avLst/>
+          </a:prstGeom>
+          <a:ln w="76200">
+            <a:solidFill>
+              <a:schemeClr val="tx1"/>
+            </a:solidFill>
+          </a:ln>
+        </p:spPr>
+        <p:style>
+          <a:lnRef idx="2">
+            <a:schemeClr val="accent1"/>
+          </a:lnRef>
+          <a:fillRef idx="0">
+            <a:schemeClr val="accent1"/>
+          </a:fillRef>
+          <a:effectRef idx="1">
+            <a:schemeClr val="accent1"/>
+          </a:effectRef>
+          <a:fontRef idx="minor">
+            <a:schemeClr val="tx1"/>
+          </a:fontRef>
+        </p:style>
+      </p:cxnSp>
+      <p:cxnSp>
+        <p:nvCxnSpPr>
+          <p:cNvPr id="29" name="Tuwid na Konektor 28">
+            <a:extLst>
+              <a:ext uri="{FF2B5EF4-FFF2-40B4-BE49-F238E27FC236}">
+                <a16:creationId xmlns:a16="http://schemas.microsoft.com/office/drawing/2014/main" id="{A7C4D7B7-3B5A-CB22-185B-D3D41E95D8EA}"/>
+              </a:ext>
+            </a:extLst>
+          </p:cNvPr>
+          <p:cNvCxnSpPr>
+            <a:cxnSpLocks/>
+          </p:cNvCxnSpPr>
+          <p:nvPr/>
+        </p:nvCxnSpPr>
+        <p:spPr>
+          <a:xfrm flipV="1">
+            <a:off x="4917451" y="3768877"/>
+            <a:ext cx="63982" cy="2938806"/>
+          </a:xfrm>
+          <a:prstGeom prst="line">
+            <a:avLst/>
+          </a:prstGeom>
+          <a:ln w="76200">
+            <a:solidFill>
+              <a:schemeClr val="tx1"/>
+            </a:solidFill>
+          </a:ln>
+        </p:spPr>
+        <p:style>
+          <a:lnRef idx="2">
+            <a:schemeClr val="accent1"/>
+          </a:lnRef>
+          <a:fillRef idx="0">
+            <a:schemeClr val="accent1"/>
+          </a:fillRef>
+          <a:effectRef idx="1">
+            <a:schemeClr val="accent1"/>
+          </a:effectRef>
+          <a:fontRef idx="minor">
+            <a:schemeClr val="tx1"/>
+          </a:fontRef>
+        </p:style>
+      </p:cxnSp>
+      <p:cxnSp>
+        <p:nvCxnSpPr>
+          <p:cNvPr id="34" name="Tuwid na Konektor 33">
+            <a:extLst>
+              <a:ext uri="{FF2B5EF4-FFF2-40B4-BE49-F238E27FC236}">
+                <a16:creationId xmlns:a16="http://schemas.microsoft.com/office/drawing/2014/main" id="{B331D0D4-486A-833F-ECCC-E20CE2CAB44D}"/>
+              </a:ext>
+            </a:extLst>
+          </p:cNvPr>
+          <p:cNvCxnSpPr>
+            <a:cxnSpLocks/>
+          </p:cNvCxnSpPr>
+          <p:nvPr/>
+        </p:nvCxnSpPr>
+        <p:spPr>
+          <a:xfrm flipV="1">
+            <a:off x="2882900" y="6419122"/>
+            <a:ext cx="0" cy="288561"/>
+          </a:xfrm>
+          <a:prstGeom prst="line">
+            <a:avLst/>
+          </a:prstGeom>
+          <a:ln w="76200">
+            <a:solidFill>
+              <a:schemeClr val="tx1"/>
+            </a:solidFill>
+          </a:ln>
+        </p:spPr>
+        <p:style>
+          <a:lnRef idx="2">
+            <a:schemeClr val="accent1"/>
+          </a:lnRef>
+          <a:fillRef idx="0">
+            <a:schemeClr val="accent1"/>
+          </a:fillRef>
+          <a:effectRef idx="1">
+            <a:schemeClr val="accent1"/>
+          </a:effectRef>
+          <a:fontRef idx="minor">
+            <a:schemeClr val="tx1"/>
+          </a:fontRef>
+        </p:style>
+      </p:cxnSp>
+      <p:pic>
+        <p:nvPicPr>
+          <p:cNvPr id="9" name="Larawan 8" descr="Isang larawang naglalaman ng electronics, makina, sapatos&#10;&#10;Maaaring hindi tama ang nilalamang na-generate ng AI.">
+            <a:extLst>
+              <a:ext uri="{FF2B5EF4-FFF2-40B4-BE49-F238E27FC236}">
+                <a16:creationId xmlns:a16="http://schemas.microsoft.com/office/drawing/2014/main" id="{58E098F7-84C3-A39F-EE6E-2A87EC8547CE}"/>
+              </a:ext>
+            </a:extLst>
+          </p:cNvPr>
+          <p:cNvPicPr>
+            <a:picLocks noChangeAspect="1"/>
+          </p:cNvPicPr>
+          <p:nvPr/>
+        </p:nvPicPr>
+        <p:blipFill>
+          <a:blip r:embed="rId6">
+            <a:extLst>
+              <a:ext uri="{BEBA8EAE-BF5A-486C-A8C5-ECC9F3942E4B}">
+                <a14:imgProps xmlns:a14="http://schemas.microsoft.com/office/drawing/2010/main">
+                  <a14:imgLayer r:embed="rId7">
+                    <a14:imgEffect>
+                      <a14:backgroundRemoval t="9985" b="89990" l="9993" r="90169">
+                        <a14:foregroundMark x1="76107" y1="31250" x2="80664" y2="48438"/>
+                        <a14:foregroundMark x1="80664" y1="48438" x2="81934" y2="49951"/>
+                        <a14:foregroundMark x1="79557" y1="29248" x2="85124" y2="28247"/>
+                        <a14:foregroundMark x1="80599" y1="33643" x2="87240" y2="31836"/>
+                        <a14:foregroundMark x1="79264" y1="39209" x2="87240" y2="37012"/>
+                        <a14:foregroundMark x1="80599" y1="43384" x2="89095" y2="41382"/>
+                        <a14:foregroundMark x1="81673" y1="52734" x2="90169" y2="50952"/>
+                      </a14:backgroundRemoval>
+                    </a14:imgEffect>
+                  </a14:imgLayer>
+                </a14:imgProps>
+              </a:ext>
+              <a:ext uri="{28A0092B-C50C-407E-A947-70E740481C1C}">
+                <a14:useLocalDpi xmlns:a14="http://schemas.microsoft.com/office/drawing/2010/main" val="0"/>
+              </a:ext>
+            </a:extLst>
+          </a:blip>
+          <a:stretch>
+            <a:fillRect/>
+          </a:stretch>
+        </p:blipFill>
+        <p:spPr>
+          <a:xfrm rot="17220845">
+            <a:off x="3077875" y="-541309"/>
+            <a:ext cx="5143500" cy="6858000"/>
+          </a:xfrm>
+          <a:prstGeom prst="rect">
+            <a:avLst/>
+          </a:prstGeom>
+        </p:spPr>
+      </p:pic>
+      <p:cxnSp>
+        <p:nvCxnSpPr>
+          <p:cNvPr id="41" name="Tuwid na Konektor 40">
+            <a:extLst>
+              <a:ext uri="{FF2B5EF4-FFF2-40B4-BE49-F238E27FC236}">
+                <a16:creationId xmlns:a16="http://schemas.microsoft.com/office/drawing/2014/main" id="{7A1D2D19-B19E-1177-D7C1-E1FDDCED58ED}"/>
+              </a:ext>
+            </a:extLst>
+          </p:cNvPr>
+          <p:cNvCxnSpPr>
+            <a:cxnSpLocks/>
+          </p:cNvCxnSpPr>
+          <p:nvPr/>
+        </p:nvCxnSpPr>
+        <p:spPr>
+          <a:xfrm>
+            <a:off x="11127477" y="5507128"/>
+            <a:ext cx="0" cy="671006"/>
+          </a:xfrm>
+          <a:prstGeom prst="line">
+            <a:avLst/>
+          </a:prstGeom>
+          <a:ln w="76200">
+            <a:solidFill>
+              <a:schemeClr val="accent2"/>
+            </a:solidFill>
+          </a:ln>
+        </p:spPr>
+        <p:style>
+          <a:lnRef idx="2">
+            <a:schemeClr val="accent1"/>
+          </a:lnRef>
+          <a:fillRef idx="0">
+            <a:schemeClr val="accent1"/>
+          </a:fillRef>
+          <a:effectRef idx="1">
+            <a:schemeClr val="accent1"/>
+          </a:effectRef>
+          <a:fontRef idx="minor">
+            <a:schemeClr val="tx1"/>
+          </a:fontRef>
+        </p:style>
+      </p:cxnSp>
+      <p:cxnSp>
+        <p:nvCxnSpPr>
+          <p:cNvPr id="43" name="Tuwid na Konektor 42">
+            <a:extLst>
+              <a:ext uri="{FF2B5EF4-FFF2-40B4-BE49-F238E27FC236}">
+                <a16:creationId xmlns:a16="http://schemas.microsoft.com/office/drawing/2014/main" id="{DD27BB06-D182-F8A4-53BD-99D1539DEE0D}"/>
+              </a:ext>
+            </a:extLst>
+          </p:cNvPr>
+          <p:cNvCxnSpPr>
+            <a:cxnSpLocks/>
+          </p:cNvCxnSpPr>
+          <p:nvPr/>
+        </p:nvCxnSpPr>
+        <p:spPr>
+          <a:xfrm flipV="1">
+            <a:off x="5268036" y="5507128"/>
+            <a:ext cx="5859441" cy="16847"/>
+          </a:xfrm>
+          <a:prstGeom prst="line">
+            <a:avLst/>
+          </a:prstGeom>
+          <a:ln w="76200">
+            <a:solidFill>
+              <a:schemeClr val="accent2"/>
+            </a:solidFill>
+          </a:ln>
+        </p:spPr>
+        <p:style>
+          <a:lnRef idx="2">
+            <a:schemeClr val="accent1"/>
+          </a:lnRef>
+          <a:fillRef idx="0">
+            <a:schemeClr val="accent1"/>
+          </a:fillRef>
+          <a:effectRef idx="1">
+            <a:schemeClr val="accent1"/>
+          </a:effectRef>
+          <a:fontRef idx="minor">
+            <a:schemeClr val="tx1"/>
+          </a:fontRef>
+        </p:style>
+      </p:cxnSp>
+      <p:cxnSp>
+        <p:nvCxnSpPr>
+          <p:cNvPr id="45" name="Tuwid na Konektor 44">
+            <a:extLst>
+              <a:ext uri="{FF2B5EF4-FFF2-40B4-BE49-F238E27FC236}">
+                <a16:creationId xmlns:a16="http://schemas.microsoft.com/office/drawing/2014/main" id="{672008AE-8487-0786-8CCE-D4B3C639D7C9}"/>
+              </a:ext>
+            </a:extLst>
+          </p:cNvPr>
+          <p:cNvCxnSpPr>
+            <a:cxnSpLocks/>
+          </p:cNvCxnSpPr>
+          <p:nvPr/>
+        </p:nvCxnSpPr>
+        <p:spPr>
+          <a:xfrm>
+            <a:off x="5304534" y="3777301"/>
+            <a:ext cx="0" cy="1729827"/>
+          </a:xfrm>
+          <a:prstGeom prst="line">
+            <a:avLst/>
+          </a:prstGeom>
+          <a:ln w="76200">
+            <a:solidFill>
+              <a:schemeClr val="accent2"/>
+            </a:solidFill>
+          </a:ln>
+        </p:spPr>
+        <p:style>
+          <a:lnRef idx="2">
+            <a:schemeClr val="accent1"/>
+          </a:lnRef>
+          <a:fillRef idx="0">
+            <a:schemeClr val="accent1"/>
+          </a:fillRef>
+          <a:effectRef idx="1">
+            <a:schemeClr val="accent1"/>
+          </a:effectRef>
+          <a:fontRef idx="minor">
+            <a:schemeClr val="tx1"/>
+          </a:fontRef>
+        </p:style>
+      </p:cxnSp>
+      <p:cxnSp>
+        <p:nvCxnSpPr>
+          <p:cNvPr id="49" name="Tuwid na Konektor 48">
+            <a:extLst>
+              <a:ext uri="{FF2B5EF4-FFF2-40B4-BE49-F238E27FC236}">
+                <a16:creationId xmlns:a16="http://schemas.microsoft.com/office/drawing/2014/main" id="{7AE54C0C-A939-D84C-A90F-1887FAF3B74D}"/>
+              </a:ext>
+            </a:extLst>
+          </p:cNvPr>
+          <p:cNvCxnSpPr>
+            <a:cxnSpLocks/>
+          </p:cNvCxnSpPr>
+          <p:nvPr/>
+        </p:nvCxnSpPr>
+        <p:spPr>
+          <a:xfrm>
+            <a:off x="10830984" y="6090337"/>
+            <a:ext cx="0" cy="688428"/>
+          </a:xfrm>
+          <a:prstGeom prst="line">
+            <a:avLst/>
+          </a:prstGeom>
+          <a:ln w="76200">
+            <a:solidFill>
+              <a:schemeClr val="tx1"/>
+            </a:solidFill>
+          </a:ln>
+        </p:spPr>
+        <p:style>
+          <a:lnRef idx="2">
+            <a:schemeClr val="accent1"/>
+          </a:lnRef>
+          <a:fillRef idx="0">
+            <a:schemeClr val="accent1"/>
+          </a:fillRef>
+          <a:effectRef idx="1">
+            <a:schemeClr val="accent1"/>
+          </a:effectRef>
+          <a:fontRef idx="minor">
+            <a:schemeClr val="tx1"/>
+          </a:fontRef>
+        </p:style>
+      </p:cxnSp>
+      <p:cxnSp>
+        <p:nvCxnSpPr>
+          <p:cNvPr id="56" name="Tuwid na Konektor 55">
+            <a:extLst>
+              <a:ext uri="{FF2B5EF4-FFF2-40B4-BE49-F238E27FC236}">
+                <a16:creationId xmlns:a16="http://schemas.microsoft.com/office/drawing/2014/main" id="{D8679540-1F93-70EB-E991-177820B1032D}"/>
+              </a:ext>
+            </a:extLst>
+          </p:cNvPr>
+          <p:cNvCxnSpPr>
+            <a:cxnSpLocks/>
+          </p:cNvCxnSpPr>
+          <p:nvPr/>
+        </p:nvCxnSpPr>
+        <p:spPr>
+          <a:xfrm>
+            <a:off x="5082540" y="6647722"/>
+            <a:ext cx="5748444" cy="0"/>
+          </a:xfrm>
+          <a:prstGeom prst="line">
+            <a:avLst/>
+          </a:prstGeom>
+          <a:ln w="76200">
+            <a:solidFill>
+              <a:schemeClr val="tx1"/>
+            </a:solidFill>
+          </a:ln>
+        </p:spPr>
+        <p:style>
+          <a:lnRef idx="2">
+            <a:schemeClr val="accent1"/>
+          </a:lnRef>
+          <a:fillRef idx="0">
+            <a:schemeClr val="accent1"/>
+          </a:fillRef>
+          <a:effectRef idx="1">
+            <a:schemeClr val="accent1"/>
+          </a:effectRef>
+          <a:fontRef idx="minor">
+            <a:schemeClr val="tx1"/>
+          </a:fontRef>
+        </p:style>
+      </p:cxnSp>
+      <p:cxnSp>
+        <p:nvCxnSpPr>
+          <p:cNvPr id="60" name="Tuwid na Konektor 59">
+            <a:extLst>
+              <a:ext uri="{FF2B5EF4-FFF2-40B4-BE49-F238E27FC236}">
+                <a16:creationId xmlns:a16="http://schemas.microsoft.com/office/drawing/2014/main" id="{55FD0A6C-4574-5694-2252-C29899165628}"/>
+              </a:ext>
+            </a:extLst>
+          </p:cNvPr>
+          <p:cNvCxnSpPr>
+            <a:cxnSpLocks/>
+          </p:cNvCxnSpPr>
+          <p:nvPr/>
+        </p:nvCxnSpPr>
+        <p:spPr>
+          <a:xfrm flipH="1" flipV="1">
+            <a:off x="4981433" y="3777301"/>
+            <a:ext cx="107760" cy="2870421"/>
+          </a:xfrm>
+          <a:prstGeom prst="line">
+            <a:avLst/>
+          </a:prstGeom>
+          <a:ln w="76200">
+            <a:solidFill>
+              <a:schemeClr val="tx1"/>
+            </a:solidFill>
+          </a:ln>
+        </p:spPr>
+        <p:style>
+          <a:lnRef idx="2">
+            <a:schemeClr val="accent1"/>
+          </a:lnRef>
+          <a:fillRef idx="0">
+            <a:schemeClr val="accent1"/>
+          </a:fillRef>
+          <a:effectRef idx="1">
+            <a:schemeClr val="accent1"/>
+          </a:effectRef>
+          <a:fontRef idx="minor">
+            <a:schemeClr val="tx1"/>
+          </a:fontRef>
+        </p:style>
+      </p:cxnSp>
+      <p:cxnSp>
+        <p:nvCxnSpPr>
+          <p:cNvPr id="63" name="Tuwid na Konektor 62">
+            <a:extLst>
+              <a:ext uri="{FF2B5EF4-FFF2-40B4-BE49-F238E27FC236}">
+                <a16:creationId xmlns:a16="http://schemas.microsoft.com/office/drawing/2014/main" id="{8A420474-EEE4-D544-190C-911DC971BAA6}"/>
+              </a:ext>
+            </a:extLst>
+          </p:cNvPr>
+          <p:cNvCxnSpPr>
+            <a:cxnSpLocks/>
+          </p:cNvCxnSpPr>
+          <p:nvPr/>
+        </p:nvCxnSpPr>
+        <p:spPr>
+          <a:xfrm flipH="1">
+            <a:off x="3501712" y="3139440"/>
+            <a:ext cx="849308" cy="220980"/>
+          </a:xfrm>
+          <a:prstGeom prst="line">
+            <a:avLst/>
+          </a:prstGeom>
+          <a:ln w="76200">
+            <a:solidFill>
+              <a:schemeClr val="accent2"/>
+            </a:solidFill>
+          </a:ln>
+        </p:spPr>
+        <p:style>
+          <a:lnRef idx="2">
+            <a:schemeClr val="accent1"/>
+          </a:lnRef>
+          <a:fillRef idx="0">
+            <a:schemeClr val="accent1"/>
+          </a:fillRef>
+          <a:effectRef idx="1">
+            <a:schemeClr val="accent1"/>
+          </a:effectRef>
+          <a:fontRef idx="minor">
+            <a:schemeClr val="tx1"/>
+          </a:fontRef>
+        </p:style>
+      </p:cxnSp>
+      <p:cxnSp>
+        <p:nvCxnSpPr>
+          <p:cNvPr id="64" name="Tuwid na Konektor 63">
+            <a:extLst>
+              <a:ext uri="{FF2B5EF4-FFF2-40B4-BE49-F238E27FC236}">
+                <a16:creationId xmlns:a16="http://schemas.microsoft.com/office/drawing/2014/main" id="{D2660EFA-7708-9AF7-E162-84947C02B45A}"/>
+              </a:ext>
+            </a:extLst>
+          </p:cNvPr>
+          <p:cNvCxnSpPr>
+            <a:cxnSpLocks/>
+          </p:cNvCxnSpPr>
+          <p:nvPr/>
+        </p:nvCxnSpPr>
+        <p:spPr>
+          <a:xfrm>
+            <a:off x="6542376" y="3139440"/>
+            <a:ext cx="955933" cy="0"/>
+          </a:xfrm>
+          <a:prstGeom prst="line">
+            <a:avLst/>
+          </a:prstGeom>
+          <a:ln w="76200">
+            <a:solidFill>
+              <a:schemeClr val="accent2"/>
+            </a:solidFill>
+          </a:ln>
+        </p:spPr>
+        <p:style>
+          <a:lnRef idx="2">
+            <a:schemeClr val="accent1"/>
+          </a:lnRef>
+          <a:fillRef idx="0">
+            <a:schemeClr val="accent1"/>
+          </a:fillRef>
+          <a:effectRef idx="1">
+            <a:schemeClr val="accent1"/>
+          </a:effectRef>
+          <a:fontRef idx="minor">
+            <a:schemeClr val="tx1"/>
+          </a:fontRef>
+        </p:style>
+      </p:cxnSp>
+      <p:cxnSp>
+        <p:nvCxnSpPr>
+          <p:cNvPr id="70" name="Tuwid na Konektor 69">
+            <a:extLst>
+              <a:ext uri="{FF2B5EF4-FFF2-40B4-BE49-F238E27FC236}">
+                <a16:creationId xmlns:a16="http://schemas.microsoft.com/office/drawing/2014/main" id="{F9FB7717-14F8-CB17-204C-56D8E379AAC0}"/>
+              </a:ext>
+            </a:extLst>
+          </p:cNvPr>
+          <p:cNvCxnSpPr>
+            <a:cxnSpLocks/>
+          </p:cNvCxnSpPr>
+          <p:nvPr/>
+        </p:nvCxnSpPr>
+        <p:spPr>
+          <a:xfrm flipH="1">
+            <a:off x="6542376" y="2238375"/>
+            <a:ext cx="955933" cy="519368"/>
+          </a:xfrm>
+          <a:prstGeom prst="line">
+            <a:avLst/>
+          </a:prstGeom>
+          <a:ln w="76200">
+            <a:solidFill>
+              <a:schemeClr val="tx1"/>
+            </a:solidFill>
+          </a:ln>
+        </p:spPr>
+        <p:style>
+          <a:lnRef idx="2">
+            <a:schemeClr val="accent1"/>
+          </a:lnRef>
+          <a:fillRef idx="0">
+            <a:schemeClr val="accent1"/>
+          </a:fillRef>
+          <a:effectRef idx="1">
+            <a:schemeClr val="accent1"/>
+          </a:effectRef>
+          <a:fontRef idx="minor">
+            <a:schemeClr val="tx1"/>
+          </a:fontRef>
+        </p:style>
+      </p:cxnSp>
+      <p:cxnSp>
+        <p:nvCxnSpPr>
+          <p:cNvPr id="71" name="Tuwid na Konektor 70">
+            <a:extLst>
+              <a:ext uri="{FF2B5EF4-FFF2-40B4-BE49-F238E27FC236}">
+                <a16:creationId xmlns:a16="http://schemas.microsoft.com/office/drawing/2014/main" id="{34C20456-FD52-18F1-0AA2-07B7AB50CD63}"/>
+              </a:ext>
+            </a:extLst>
+          </p:cNvPr>
+          <p:cNvCxnSpPr>
+            <a:cxnSpLocks/>
+          </p:cNvCxnSpPr>
+          <p:nvPr/>
+        </p:nvCxnSpPr>
+        <p:spPr>
+          <a:xfrm flipH="1" flipV="1">
+            <a:off x="3501712" y="2419350"/>
+            <a:ext cx="923095" cy="338393"/>
+          </a:xfrm>
+          <a:prstGeom prst="line">
+            <a:avLst/>
+          </a:prstGeom>
+          <a:ln w="76200">
+            <a:solidFill>
+              <a:schemeClr val="tx1"/>
+            </a:solidFill>
+          </a:ln>
+        </p:spPr>
+        <p:style>
+          <a:lnRef idx="2">
+            <a:schemeClr val="accent1"/>
+          </a:lnRef>
+          <a:fillRef idx="0">
+            <a:schemeClr val="accent1"/>
+          </a:fillRef>
+          <a:effectRef idx="1">
+            <a:schemeClr val="accent1"/>
+          </a:effectRef>
+          <a:fontRef idx="minor">
+            <a:schemeClr val="tx1"/>
+          </a:fontRef>
+        </p:style>
+      </p:cxnSp>
+      <p:cxnSp>
+        <p:nvCxnSpPr>
+          <p:cNvPr id="76" name="Tuwid na Konektor 75">
+            <a:extLst>
+              <a:ext uri="{FF2B5EF4-FFF2-40B4-BE49-F238E27FC236}">
+                <a16:creationId xmlns:a16="http://schemas.microsoft.com/office/drawing/2014/main" id="{DB926194-3FA3-8B2E-4A34-EA191067ACCC}"/>
+              </a:ext>
+            </a:extLst>
+          </p:cNvPr>
+          <p:cNvCxnSpPr>
+            <a:cxnSpLocks/>
+          </p:cNvCxnSpPr>
+          <p:nvPr/>
+        </p:nvCxnSpPr>
+        <p:spPr>
+          <a:xfrm>
+            <a:off x="5770224" y="3660189"/>
+            <a:ext cx="0" cy="2734994"/>
+          </a:xfrm>
+          <a:prstGeom prst="line">
+            <a:avLst/>
+          </a:prstGeom>
+          <a:ln w="76200">
+            <a:solidFill>
+              <a:schemeClr val="accent2">
+                <a:lumMod val="60000"/>
+                <a:lumOff val="40000"/>
+              </a:schemeClr>
+            </a:solidFill>
+          </a:ln>
+        </p:spPr>
+        <p:style>
+          <a:lnRef idx="2">
+            <a:schemeClr val="accent1"/>
+          </a:lnRef>
+          <a:fillRef idx="0">
+            <a:schemeClr val="accent1"/>
+          </a:fillRef>
+          <a:effectRef idx="1">
+            <a:schemeClr val="accent1"/>
+          </a:effectRef>
+          <a:fontRef idx="minor">
+            <a:schemeClr val="tx1"/>
+          </a:fontRef>
+        </p:style>
+      </p:cxnSp>
+      <p:cxnSp>
+        <p:nvCxnSpPr>
+          <p:cNvPr id="79" name="Tuwid na Konektor 78">
+            <a:extLst>
+              <a:ext uri="{FF2B5EF4-FFF2-40B4-BE49-F238E27FC236}">
+                <a16:creationId xmlns:a16="http://schemas.microsoft.com/office/drawing/2014/main" id="{ACAE36F8-CE50-21FA-59A2-6B6D48CB6791}"/>
+              </a:ext>
+            </a:extLst>
+          </p:cNvPr>
+          <p:cNvCxnSpPr>
+            <a:cxnSpLocks/>
+          </p:cNvCxnSpPr>
+          <p:nvPr/>
+        </p:nvCxnSpPr>
+        <p:spPr>
+          <a:xfrm flipV="1">
+            <a:off x="5770224" y="6379482"/>
+            <a:ext cx="4738452" cy="15701"/>
+          </a:xfrm>
+          <a:prstGeom prst="line">
+            <a:avLst/>
+          </a:prstGeom>
+          <a:ln w="76200">
+            <a:solidFill>
+              <a:schemeClr val="accent2">
+                <a:lumMod val="60000"/>
+                <a:lumOff val="40000"/>
+              </a:schemeClr>
+            </a:solidFill>
+          </a:ln>
+        </p:spPr>
+        <p:style>
+          <a:lnRef idx="2">
+            <a:schemeClr val="accent1"/>
+          </a:lnRef>
+          <a:fillRef idx="0">
+            <a:schemeClr val="accent1"/>
+          </a:fillRef>
+          <a:effectRef idx="1">
+            <a:schemeClr val="accent1"/>
+          </a:effectRef>
+          <a:fontRef idx="minor">
+            <a:schemeClr val="tx1"/>
+          </a:fontRef>
+        </p:style>
+      </p:cxnSp>
+      <p:cxnSp>
+        <p:nvCxnSpPr>
+          <p:cNvPr id="81" name="Tuwid na Konektor 80">
+            <a:extLst>
+              <a:ext uri="{FF2B5EF4-FFF2-40B4-BE49-F238E27FC236}">
+                <a16:creationId xmlns:a16="http://schemas.microsoft.com/office/drawing/2014/main" id="{0FCDA674-4FF1-535B-3045-C57B7A37C950}"/>
+              </a:ext>
+            </a:extLst>
+          </p:cNvPr>
+          <p:cNvCxnSpPr>
+            <a:cxnSpLocks/>
+          </p:cNvCxnSpPr>
+          <p:nvPr/>
+        </p:nvCxnSpPr>
+        <p:spPr>
+          <a:xfrm flipH="1">
+            <a:off x="10442137" y="6089525"/>
+            <a:ext cx="6300" cy="337422"/>
+          </a:xfrm>
+          <a:prstGeom prst="line">
+            <a:avLst/>
+          </a:prstGeom>
+          <a:ln w="76200">
+            <a:solidFill>
+              <a:schemeClr val="accent2">
+                <a:lumMod val="60000"/>
+                <a:lumOff val="40000"/>
+              </a:schemeClr>
+            </a:solidFill>
+          </a:ln>
+        </p:spPr>
+        <p:style>
+          <a:lnRef idx="2">
+            <a:schemeClr val="accent1"/>
+          </a:lnRef>
+          <a:fillRef idx="0">
+            <a:schemeClr val="accent1"/>
+          </a:fillRef>
+          <a:effectRef idx="1">
+            <a:schemeClr val="accent1"/>
+          </a:effectRef>
+          <a:fontRef idx="minor">
+            <a:schemeClr val="tx1"/>
+          </a:fontRef>
+        </p:style>
+      </p:cxnSp>
+      <p:cxnSp>
+        <p:nvCxnSpPr>
+          <p:cNvPr id="87" name="Tuwid na Konektor 86">
+            <a:extLst>
+              <a:ext uri="{FF2B5EF4-FFF2-40B4-BE49-F238E27FC236}">
+                <a16:creationId xmlns:a16="http://schemas.microsoft.com/office/drawing/2014/main" id="{50C66F1A-0AB2-430C-9B8E-024DF33514E8}"/>
+              </a:ext>
+            </a:extLst>
+          </p:cNvPr>
+          <p:cNvCxnSpPr>
+            <a:cxnSpLocks/>
+          </p:cNvCxnSpPr>
+          <p:nvPr/>
+        </p:nvCxnSpPr>
+        <p:spPr>
+          <a:xfrm flipH="1">
+            <a:off x="5941048" y="3660189"/>
+            <a:ext cx="3544" cy="2071912"/>
+          </a:xfrm>
+          <a:prstGeom prst="line">
+            <a:avLst/>
+          </a:prstGeom>
+          <a:ln w="76200">
+            <a:solidFill>
+              <a:schemeClr val="accent1">
+                <a:lumMod val="60000"/>
+                <a:lumOff val="40000"/>
+              </a:schemeClr>
+            </a:solidFill>
+          </a:ln>
+        </p:spPr>
+        <p:style>
+          <a:lnRef idx="2">
+            <a:schemeClr val="accent1"/>
+          </a:lnRef>
+          <a:fillRef idx="0">
+            <a:schemeClr val="accent1"/>
+          </a:fillRef>
+          <a:effectRef idx="1">
+            <a:schemeClr val="accent1"/>
+          </a:effectRef>
+          <a:fontRef idx="minor">
+            <a:schemeClr val="tx1"/>
+          </a:fontRef>
+        </p:style>
+      </p:cxnSp>
+      <p:cxnSp>
+        <p:nvCxnSpPr>
+          <p:cNvPr id="88" name="Tuwid na Konektor 87">
+            <a:extLst>
+              <a:ext uri="{FF2B5EF4-FFF2-40B4-BE49-F238E27FC236}">
+                <a16:creationId xmlns:a16="http://schemas.microsoft.com/office/drawing/2014/main" id="{7F031EDE-2095-7AE3-5028-1F9DF3EC704F}"/>
+              </a:ext>
+            </a:extLst>
+          </p:cNvPr>
+          <p:cNvCxnSpPr>
+            <a:cxnSpLocks/>
+          </p:cNvCxnSpPr>
+          <p:nvPr/>
+        </p:nvCxnSpPr>
+        <p:spPr>
+          <a:xfrm>
+            <a:off x="5931323" y="5702850"/>
+            <a:ext cx="4532227" cy="0"/>
+          </a:xfrm>
+          <a:prstGeom prst="line">
+            <a:avLst/>
+          </a:prstGeom>
+          <a:ln w="76200">
+            <a:solidFill>
+              <a:schemeClr val="accent1">
+                <a:lumMod val="60000"/>
+                <a:lumOff val="40000"/>
+              </a:schemeClr>
+            </a:solidFill>
+          </a:ln>
+        </p:spPr>
+        <p:style>
+          <a:lnRef idx="2">
+            <a:schemeClr val="accent1"/>
+          </a:lnRef>
+          <a:fillRef idx="0">
+            <a:schemeClr val="accent1"/>
+          </a:fillRef>
+          <a:effectRef idx="1">
+            <a:schemeClr val="accent1"/>
+          </a:effectRef>
+          <a:fontRef idx="minor">
+            <a:schemeClr val="tx1"/>
+          </a:fontRef>
+        </p:style>
+      </p:cxnSp>
+      <p:cxnSp>
+        <p:nvCxnSpPr>
+          <p:cNvPr id="89" name="Tuwid na Konektor 88">
+            <a:extLst>
+              <a:ext uri="{FF2B5EF4-FFF2-40B4-BE49-F238E27FC236}">
+                <a16:creationId xmlns:a16="http://schemas.microsoft.com/office/drawing/2014/main" id="{DEC05CA9-1C24-B9C9-7F6C-575DCECD51AD}"/>
+              </a:ext>
+            </a:extLst>
+          </p:cNvPr>
+          <p:cNvCxnSpPr>
+            <a:cxnSpLocks/>
+          </p:cNvCxnSpPr>
+          <p:nvPr/>
+        </p:nvCxnSpPr>
+        <p:spPr>
+          <a:xfrm>
+            <a:off x="10442137" y="5668528"/>
+            <a:ext cx="0" cy="350035"/>
+          </a:xfrm>
+          <a:prstGeom prst="line">
+            <a:avLst/>
+          </a:prstGeom>
+          <a:ln w="76200">
+            <a:solidFill>
+              <a:schemeClr val="accent1">
+                <a:lumMod val="60000"/>
+                <a:lumOff val="40000"/>
+              </a:schemeClr>
+            </a:solidFill>
+          </a:ln>
+        </p:spPr>
+        <p:style>
+          <a:lnRef idx="2">
+            <a:schemeClr val="accent1"/>
+          </a:lnRef>
+          <a:fillRef idx="0">
+            <a:schemeClr val="accent1"/>
+          </a:fillRef>
+          <a:effectRef idx="1">
+            <a:schemeClr val="accent1"/>
+          </a:effectRef>
+          <a:fontRef idx="minor">
+            <a:schemeClr val="tx1"/>
+          </a:fontRef>
+        </p:style>
+      </p:cxnSp>
+      <p:cxnSp>
+        <p:nvCxnSpPr>
+          <p:cNvPr id="97" name="Tuwid na Konektor 96">
+            <a:extLst>
+              <a:ext uri="{FF2B5EF4-FFF2-40B4-BE49-F238E27FC236}">
+                <a16:creationId xmlns:a16="http://schemas.microsoft.com/office/drawing/2014/main" id="{36412630-763A-3EC2-3D31-F3AD2DC2B870}"/>
+              </a:ext>
+            </a:extLst>
+          </p:cNvPr>
+          <p:cNvCxnSpPr>
+            <a:cxnSpLocks/>
+          </p:cNvCxnSpPr>
+          <p:nvPr/>
+        </p:nvCxnSpPr>
+        <p:spPr>
+          <a:xfrm>
+            <a:off x="6096000" y="3677175"/>
+            <a:ext cx="0" cy="2602715"/>
+          </a:xfrm>
+          <a:prstGeom prst="line">
+            <a:avLst/>
+          </a:prstGeom>
+          <a:ln w="76200">
+            <a:solidFill>
+              <a:schemeClr val="accent4">
+                <a:lumMod val="60000"/>
+                <a:lumOff val="40000"/>
+              </a:schemeClr>
+            </a:solidFill>
+          </a:ln>
+        </p:spPr>
+        <p:style>
+          <a:lnRef idx="2">
+            <a:schemeClr val="accent1"/>
+          </a:lnRef>
+          <a:fillRef idx="0">
+            <a:schemeClr val="accent1"/>
+          </a:fillRef>
+          <a:effectRef idx="1">
+            <a:schemeClr val="accent1"/>
+          </a:effectRef>
+          <a:fontRef idx="minor">
+            <a:schemeClr val="tx1"/>
+          </a:fontRef>
+        </p:style>
+      </p:cxnSp>
+      <p:cxnSp>
+        <p:nvCxnSpPr>
+          <p:cNvPr id="98" name="Tuwid na Konektor 97">
+            <a:extLst>
+              <a:ext uri="{FF2B5EF4-FFF2-40B4-BE49-F238E27FC236}">
+                <a16:creationId xmlns:a16="http://schemas.microsoft.com/office/drawing/2014/main" id="{73B078BC-66B0-1B50-23E4-57281D563B27}"/>
+              </a:ext>
+            </a:extLst>
+          </p:cNvPr>
+          <p:cNvCxnSpPr>
+            <a:cxnSpLocks/>
+          </p:cNvCxnSpPr>
+          <p:nvPr/>
+        </p:nvCxnSpPr>
+        <p:spPr>
+          <a:xfrm>
+            <a:off x="6057964" y="6260758"/>
+            <a:ext cx="4125283" cy="19132"/>
+          </a:xfrm>
+          <a:prstGeom prst="line">
+            <a:avLst/>
+          </a:prstGeom>
+          <a:ln w="76200">
+            <a:solidFill>
+              <a:schemeClr val="accent4">
+                <a:lumMod val="60000"/>
+                <a:lumOff val="40000"/>
+              </a:schemeClr>
+            </a:solidFill>
+          </a:ln>
+        </p:spPr>
+        <p:style>
+          <a:lnRef idx="2">
+            <a:schemeClr val="accent1"/>
+          </a:lnRef>
+          <a:fillRef idx="0">
+            <a:schemeClr val="accent1"/>
+          </a:fillRef>
+          <a:effectRef idx="1">
+            <a:schemeClr val="accent1"/>
+          </a:effectRef>
+          <a:fontRef idx="minor">
+            <a:schemeClr val="tx1"/>
+          </a:fontRef>
+        </p:style>
+      </p:cxnSp>
+      <p:cxnSp>
+        <p:nvCxnSpPr>
+          <p:cNvPr id="99" name="Tuwid na Konektor 98">
+            <a:extLst>
+              <a:ext uri="{FF2B5EF4-FFF2-40B4-BE49-F238E27FC236}">
+                <a16:creationId xmlns:a16="http://schemas.microsoft.com/office/drawing/2014/main" id="{41333D14-28BE-520A-FAE9-40D10D45921D}"/>
+              </a:ext>
+            </a:extLst>
+          </p:cNvPr>
+          <p:cNvCxnSpPr>
+            <a:cxnSpLocks/>
+          </p:cNvCxnSpPr>
+          <p:nvPr/>
+        </p:nvCxnSpPr>
+        <p:spPr>
+          <a:xfrm>
+            <a:off x="10182344" y="6083071"/>
+            <a:ext cx="0" cy="241445"/>
+          </a:xfrm>
+          <a:prstGeom prst="line">
+            <a:avLst/>
+          </a:prstGeom>
+          <a:ln w="76200">
+            <a:solidFill>
+              <a:schemeClr val="accent4">
+                <a:lumMod val="60000"/>
+                <a:lumOff val="40000"/>
+              </a:schemeClr>
+            </a:solidFill>
+          </a:ln>
+        </p:spPr>
+        <p:style>
+          <a:lnRef idx="2">
+            <a:schemeClr val="accent1"/>
+          </a:lnRef>
+          <a:fillRef idx="0">
+            <a:schemeClr val="accent1"/>
+          </a:fillRef>
+          <a:effectRef idx="1">
+            <a:schemeClr val="accent1"/>
+          </a:effectRef>
+          <a:fontRef idx="minor">
+            <a:schemeClr val="tx1"/>
+          </a:fontRef>
+        </p:style>
+      </p:cxnSp>
+      <p:cxnSp>
+        <p:nvCxnSpPr>
+          <p:cNvPr id="103" name="Tuwid na Konektor 102">
+            <a:extLst>
+              <a:ext uri="{FF2B5EF4-FFF2-40B4-BE49-F238E27FC236}">
+                <a16:creationId xmlns:a16="http://schemas.microsoft.com/office/drawing/2014/main" id="{7471A976-20DD-1B2F-0953-BBD674A48F3A}"/>
+              </a:ext>
+            </a:extLst>
+          </p:cNvPr>
+          <p:cNvCxnSpPr>
+            <a:cxnSpLocks/>
+          </p:cNvCxnSpPr>
+          <p:nvPr/>
+        </p:nvCxnSpPr>
+        <p:spPr>
+          <a:xfrm>
+            <a:off x="6250571" y="3660189"/>
+            <a:ext cx="16329" cy="2219112"/>
+          </a:xfrm>
+          <a:prstGeom prst="line">
+            <a:avLst/>
+          </a:prstGeom>
+          <a:ln w="76200">
+            <a:solidFill>
+              <a:schemeClr val="bg2">
+                <a:lumMod val="75000"/>
+              </a:schemeClr>
+            </a:solidFill>
+          </a:ln>
+        </p:spPr>
+        <p:style>
+          <a:lnRef idx="2">
+            <a:schemeClr val="accent1"/>
+          </a:lnRef>
+          <a:fillRef idx="0">
+            <a:schemeClr val="accent1"/>
+          </a:fillRef>
+          <a:effectRef idx="1">
+            <a:schemeClr val="accent1"/>
+          </a:effectRef>
+          <a:fontRef idx="minor">
+            <a:schemeClr val="tx1"/>
+          </a:fontRef>
+        </p:style>
+      </p:cxnSp>
+      <p:cxnSp>
+        <p:nvCxnSpPr>
+          <p:cNvPr id="104" name="Tuwid na Konektor 103">
+            <a:extLst>
+              <a:ext uri="{FF2B5EF4-FFF2-40B4-BE49-F238E27FC236}">
+                <a16:creationId xmlns:a16="http://schemas.microsoft.com/office/drawing/2014/main" id="{BA0340C9-BB11-F8E8-A202-C43CDE490147}"/>
+              </a:ext>
+            </a:extLst>
+          </p:cNvPr>
+          <p:cNvCxnSpPr>
+            <a:cxnSpLocks/>
+          </p:cNvCxnSpPr>
+          <p:nvPr/>
+        </p:nvCxnSpPr>
+        <p:spPr>
+          <a:xfrm>
+            <a:off x="6239526" y="5859485"/>
+            <a:ext cx="3941915" cy="19816"/>
+          </a:xfrm>
+          <a:prstGeom prst="line">
+            <a:avLst/>
+          </a:prstGeom>
+          <a:ln w="76200">
+            <a:solidFill>
+              <a:schemeClr val="bg2">
+                <a:lumMod val="75000"/>
+              </a:schemeClr>
+            </a:solidFill>
+          </a:ln>
+        </p:spPr>
+        <p:style>
+          <a:lnRef idx="2">
+            <a:schemeClr val="accent1"/>
+          </a:lnRef>
+          <a:fillRef idx="0">
+            <a:schemeClr val="accent1"/>
+          </a:fillRef>
+          <a:effectRef idx="1">
+            <a:schemeClr val="accent1"/>
+          </a:effectRef>
+          <a:fontRef idx="minor">
+            <a:schemeClr val="tx1"/>
+          </a:fontRef>
+        </p:style>
+      </p:cxnSp>
+      <p:cxnSp>
+        <p:nvCxnSpPr>
+          <p:cNvPr id="105" name="Tuwid na Konektor 104">
+            <a:extLst>
+              <a:ext uri="{FF2B5EF4-FFF2-40B4-BE49-F238E27FC236}">
+                <a16:creationId xmlns:a16="http://schemas.microsoft.com/office/drawing/2014/main" id="{114E5BD7-A9E1-C946-1F6A-985B5C1F47E5}"/>
+              </a:ext>
+            </a:extLst>
+          </p:cNvPr>
+          <p:cNvCxnSpPr>
+            <a:cxnSpLocks/>
+          </p:cNvCxnSpPr>
+          <p:nvPr/>
+        </p:nvCxnSpPr>
+        <p:spPr>
+          <a:xfrm flipV="1">
+            <a:off x="10181113" y="5847670"/>
+            <a:ext cx="2134" cy="167899"/>
+          </a:xfrm>
+          <a:prstGeom prst="line">
+            <a:avLst/>
+          </a:prstGeom>
+          <a:ln w="76200">
+            <a:solidFill>
+              <a:schemeClr val="bg2">
+                <a:lumMod val="75000"/>
+              </a:schemeClr>
+            </a:solidFill>
+          </a:ln>
+        </p:spPr>
+        <p:style>
+          <a:lnRef idx="2">
+            <a:schemeClr val="accent1"/>
+          </a:lnRef>
+          <a:fillRef idx="0">
+            <a:schemeClr val="accent1"/>
+          </a:fillRef>
+          <a:effectRef idx="1">
+            <a:schemeClr val="accent1"/>
+          </a:effectRef>
+          <a:fontRef idx="minor">
+            <a:schemeClr val="tx1"/>
+          </a:fontRef>
+        </p:style>
+      </p:cxnSp>
+      <p:pic>
+        <p:nvPicPr>
+          <p:cNvPr id="112" name="Larawan 111">
+            <a:extLst>
+              <a:ext uri="{FF2B5EF4-FFF2-40B4-BE49-F238E27FC236}">
+                <a16:creationId xmlns:a16="http://schemas.microsoft.com/office/drawing/2014/main" id="{A6CB0F66-28CB-EE36-02B8-574FD26CE821}"/>
+              </a:ext>
+            </a:extLst>
+          </p:cNvPr>
+          <p:cNvPicPr>
+            <a:picLocks noChangeAspect="1"/>
+          </p:cNvPicPr>
+          <p:nvPr/>
+        </p:nvPicPr>
+        <p:blipFill>
+          <a:blip r:embed="rId8"/>
+          <a:srcRect r="17047"/>
+          <a:stretch/>
+        </p:blipFill>
+        <p:spPr>
+          <a:xfrm>
+            <a:off x="132080" y="258993"/>
+            <a:ext cx="4125088" cy="1609740"/>
+          </a:xfrm>
+          <a:prstGeom prst="rect">
+            <a:avLst/>
+          </a:prstGeom>
+        </p:spPr>
+      </p:pic>
+      <p:pic>
+        <p:nvPicPr>
+          <p:cNvPr id="114" name="Larawan 113">
+            <a:extLst>
+              <a:ext uri="{FF2B5EF4-FFF2-40B4-BE49-F238E27FC236}">
+                <a16:creationId xmlns:a16="http://schemas.microsoft.com/office/drawing/2014/main" id="{703FBE9A-BDBB-CFA1-EE83-2B11F422CBEC}"/>
+              </a:ext>
+            </a:extLst>
+          </p:cNvPr>
+          <p:cNvPicPr>
+            <a:picLocks noChangeAspect="1"/>
+          </p:cNvPicPr>
+          <p:nvPr/>
+        </p:nvPicPr>
+        <p:blipFill>
+          <a:blip r:embed="rId9"/>
+          <a:srcRect r="23891"/>
+          <a:stretch/>
+        </p:blipFill>
+        <p:spPr>
+          <a:xfrm rot="5400000">
+            <a:off x="9042276" y="18769"/>
+            <a:ext cx="2387915" cy="3124790"/>
+          </a:xfrm>
+          <a:prstGeom prst="rect">
+            <a:avLst/>
+          </a:prstGeom>
+        </p:spPr>
+      </p:pic>
+      <p:pic>
+        <p:nvPicPr>
+          <p:cNvPr id="115" name="Larawan 114">
+            <a:extLst>
+              <a:ext uri="{FF2B5EF4-FFF2-40B4-BE49-F238E27FC236}">
+                <a16:creationId xmlns:a16="http://schemas.microsoft.com/office/drawing/2014/main" id="{EE9D430A-8A0C-8B9F-CD43-BB8F66B6F0B4}"/>
+              </a:ext>
+            </a:extLst>
+          </p:cNvPr>
+          <p:cNvPicPr>
+            <a:picLocks noChangeAspect="1"/>
+          </p:cNvPicPr>
+          <p:nvPr/>
+        </p:nvPicPr>
+        <p:blipFill>
+          <a:blip r:embed="rId9"/>
+          <a:srcRect r="23891"/>
+          <a:stretch/>
+        </p:blipFill>
+        <p:spPr>
+          <a:xfrm>
+            <a:off x="6770416" y="107038"/>
+            <a:ext cx="1617117" cy="2116135"/>
+          </a:xfrm>
+          <a:prstGeom prst="rect">
+            <a:avLst/>
+          </a:prstGeom>
+        </p:spPr>
+      </p:pic>
+    </p:spTree>
+    <p:extLst>
+      <p:ext uri="{BB962C8B-B14F-4D97-AF65-F5344CB8AC3E}">
+        <p14:creationId xmlns:p14="http://schemas.microsoft.com/office/powerpoint/2010/main" val="1030739779"/>
+      </p:ext>
+    </p:extLst>
+  </p:cSld>
+  <p:clrMapOvr>
+    <a:masterClrMapping/>
+  </p:clrMapOvr>
+</p:sld>
+</file>
+
+<file path=ppt/slides/slide2.xml><?xml version="1.0" encoding="utf-8"?>
+<p:sld xmlns:a="http://schemas.openxmlformats.org/drawingml/2006/main" xmlns:r="http://schemas.openxmlformats.org/officeDocument/2006/relationships" xmlns:p="http://schemas.openxmlformats.org/presentationml/2006/main">
+  <p:cSld>
+    <p:spTree>
+      <p:nvGrpSpPr>
         <p:cNvPr id="1" name=""/>
         <p:cNvGrpSpPr/>
         <p:nvPr/>
@@ -3362,7 +5381,7 @@
           <p:nvPr/>
         </p:nvPicPr>
         <p:blipFill>
-          <a:blip r:embed="rId2"/>
+          <a:blip r:embed="rId3"/>
           <a:stretch>
             <a:fillRect/>
           </a:stretch>
@@ -3383,36 +5402,6 @@
             <a:extLst>
               <a:ext uri="{FF2B5EF4-FFF2-40B4-BE49-F238E27FC236}">
                 <a16:creationId xmlns:a16="http://schemas.microsoft.com/office/drawing/2014/main" id="{1F5FE275-7762-7BB9-FBDA-653EBFE7D3A0}"/>
-              </a:ext>
-            </a:extLst>
-          </p:cNvPr>
-          <p:cNvPicPr>
-            <a:picLocks noChangeAspect="1"/>
-          </p:cNvPicPr>
-          <p:nvPr/>
-        </p:nvPicPr>
-        <p:blipFill>
-          <a:blip r:embed="rId2"/>
-          <a:stretch>
-            <a:fillRect/>
-          </a:stretch>
-        </p:blipFill>
-        <p:spPr>
-          <a:xfrm>
-            <a:off x="7280666" y="1876558"/>
-            <a:ext cx="3686689" cy="1762371"/>
-          </a:xfrm>
-          <a:prstGeom prst="rect">
-            <a:avLst/>
-          </a:prstGeom>
-        </p:spPr>
-      </p:pic>
-      <p:pic>
-        <p:nvPicPr>
-          <p:cNvPr id="11" name="Larawan 10">
-            <a:extLst>
-              <a:ext uri="{FF2B5EF4-FFF2-40B4-BE49-F238E27FC236}">
-                <a16:creationId xmlns:a16="http://schemas.microsoft.com/office/drawing/2014/main" id="{30669BF6-1C5D-30F5-3F33-7F3914D9ED4F}"/>
               </a:ext>
             </a:extLst>
           </p:cNvPr>
@@ -3428,9 +5417,9 @@
           </a:stretch>
         </p:blipFill>
         <p:spPr>
-          <a:xfrm rot="10800000">
-            <a:off x="6744428" y="2975238"/>
-            <a:ext cx="5163271" cy="3553321"/>
+          <a:xfrm>
+            <a:off x="7280666" y="1876558"/>
+            <a:ext cx="3686689" cy="1762371"/>
           </a:xfrm>
           <a:prstGeom prst="rect">
             <a:avLst/>
@@ -3439,10 +5428,10 @@
       </p:pic>
       <p:pic>
         <p:nvPicPr>
-          <p:cNvPr id="13" name="Larawan 12">
-            <a:extLst>
-              <a:ext uri="{FF2B5EF4-FFF2-40B4-BE49-F238E27FC236}">
-                <a16:creationId xmlns:a16="http://schemas.microsoft.com/office/drawing/2014/main" id="{B4B8335C-8D6F-620C-2B7C-C2194E44524C}"/>
+          <p:cNvPr id="11" name="Larawan 10">
+            <a:extLst>
+              <a:ext uri="{FF2B5EF4-FFF2-40B4-BE49-F238E27FC236}">
+                <a16:creationId xmlns:a16="http://schemas.microsoft.com/office/drawing/2014/main" id="{30669BF6-1C5D-30F5-3F33-7F3914D9ED4F}"/>
               </a:ext>
             </a:extLst>
           </p:cNvPr>
@@ -3458,6 +5447,36 @@
           </a:stretch>
         </p:blipFill>
         <p:spPr>
+          <a:xfrm rot="10800000">
+            <a:off x="6744428" y="2975238"/>
+            <a:ext cx="5163271" cy="3553321"/>
+          </a:xfrm>
+          <a:prstGeom prst="rect">
+            <a:avLst/>
+          </a:prstGeom>
+        </p:spPr>
+      </p:pic>
+      <p:pic>
+        <p:nvPicPr>
+          <p:cNvPr id="13" name="Larawan 12">
+            <a:extLst>
+              <a:ext uri="{FF2B5EF4-FFF2-40B4-BE49-F238E27FC236}">
+                <a16:creationId xmlns:a16="http://schemas.microsoft.com/office/drawing/2014/main" id="{B4B8335C-8D6F-620C-2B7C-C2194E44524C}"/>
+              </a:ext>
+            </a:extLst>
+          </p:cNvPr>
+          <p:cNvPicPr>
+            <a:picLocks noChangeAspect="1"/>
+          </p:cNvPicPr>
+          <p:nvPr/>
+        </p:nvPicPr>
+        <p:blipFill>
+          <a:blip r:embed="rId5"/>
+          <a:stretch>
+            <a:fillRect/>
+          </a:stretch>
+        </p:blipFill>
+        <p:spPr>
           <a:xfrm rot="5400000">
             <a:off x="808693" y="4042631"/>
             <a:ext cx="1971950" cy="2962688"/>
@@ -3697,11 +5716,11 @@
           <p:nvPr/>
         </p:nvPicPr>
         <p:blipFill>
-          <a:blip r:embed="rId5">
+          <a:blip r:embed="rId6">
             <a:extLst>
               <a:ext uri="{BEBA8EAE-BF5A-486C-A8C5-ECC9F3942E4B}">
                 <a14:imgProps xmlns:a14="http://schemas.microsoft.com/office/drawing/2010/main">
-                  <a14:imgLayer r:embed="rId6">
+                  <a14:imgLayer r:embed="rId7">
                     <a14:imgEffect>
                       <a14:backgroundRemoval t="9985" b="89990" l="9993" r="90169">
                         <a14:foregroundMark x1="76107" y1="31250" x2="80664" y2="48438"/>
@@ -4729,7 +6748,7 @@
           <p:nvPr/>
         </p:nvPicPr>
         <p:blipFill>
-          <a:blip r:embed="rId7"/>
+          <a:blip r:embed="rId8"/>
           <a:srcRect r="17047"/>
           <a:stretch/>
         </p:blipFill>
@@ -4758,7 +6777,7 @@
           <p:nvPr/>
         </p:nvPicPr>
         <p:blipFill>
-          <a:blip r:embed="rId8"/>
+          <a:blip r:embed="rId9"/>
           <a:srcRect r="23891"/>
           <a:stretch/>
         </p:blipFill>
@@ -4787,7 +6806,7 @@
           <p:nvPr/>
         </p:nvPicPr>
         <p:blipFill>
-          <a:blip r:embed="rId8"/>
+          <a:blip r:embed="rId9"/>
           <a:srcRect r="23891"/>
           <a:stretch/>
         </p:blipFill>
@@ -5127,4 +7146,319 @@
     </a:ext>
   </a:extLst>
 </a:theme>
+</file>
+
+<file path=ppt/theme/theme2.xml><?xml version="1.0" encoding="utf-8"?>
+<a:theme xmlns:a="http://schemas.openxmlformats.org/drawingml/2006/main" name="Office Theme">
+  <a:themeElements>
+    <a:clrScheme name="Office">
+      <a:dk1>
+        <a:sysClr val="windowText" lastClr="000000"/>
+      </a:dk1>
+      <a:lt1>
+        <a:sysClr val="window" lastClr="FFFFFF"/>
+      </a:lt1>
+      <a:dk2>
+        <a:srgbClr val="0E2841"/>
+      </a:dk2>
+      <a:lt2>
+        <a:srgbClr val="E8E8E8"/>
+      </a:lt2>
+      <a:accent1>
+        <a:srgbClr val="156082"/>
+      </a:accent1>
+      <a:accent2>
+        <a:srgbClr val="E97132"/>
+      </a:accent2>
+      <a:accent3>
+        <a:srgbClr val="196B24"/>
+      </a:accent3>
+      <a:accent4>
+        <a:srgbClr val="0F9ED5"/>
+      </a:accent4>
+      <a:accent5>
+        <a:srgbClr val="A02B93"/>
+      </a:accent5>
+      <a:accent6>
+        <a:srgbClr val="4EA72E"/>
+      </a:accent6>
+      <a:hlink>
+        <a:srgbClr val="467886"/>
+      </a:hlink>
+      <a:folHlink>
+        <a:srgbClr val="96607D"/>
+      </a:folHlink>
+    </a:clrScheme>
+    <a:fontScheme name="Office">
+      <a:majorFont>
+        <a:latin typeface="Aptos Display" panose="02110004020202020204"/>
+        <a:ea typeface=""/>
+        <a:cs typeface=""/>
+        <a:font script="Jpan" typeface="游ゴシック Light"/>
+        <a:font script="Hang" typeface="맑은 고딕"/>
+        <a:font script="Hans" typeface="等线 Light"/>
+        <a:font script="Hant" typeface="新細明體"/>
+        <a:font script="Arab" typeface="Times New Roman"/>
+        <a:font script="Hebr" typeface="Times New Roman"/>
+        <a:font script="Thai" typeface="Angsana New"/>
+        <a:font script="Ethi" typeface="Nyala"/>
+        <a:font script="Beng" typeface="Vrinda"/>
+        <a:font script="Gujr" typeface="Shruti"/>
+        <a:font script="Khmr" typeface="MoolBoran"/>
+        <a:font script="Knda" typeface="Tunga"/>
+        <a:font script="Guru" typeface="Raavi"/>
+        <a:font script="Cans" typeface="Euphemia"/>
+        <a:font script="Cher" typeface="Plantagenet Cherokee"/>
+        <a:font script="Yiii" typeface="Microsoft Yi Baiti"/>
+        <a:font script="Tibt" typeface="Microsoft Himalaya"/>
+        <a:font script="Thaa" typeface="MV Boli"/>
+        <a:font script="Deva" typeface="Mangal"/>
+        <a:font script="Telu" typeface="Gautami"/>
+        <a:font script="Taml" typeface="Latha"/>
+        <a:font script="Syrc" typeface="Estrangelo Edessa"/>
+        <a:font script="Orya" typeface="Kalinga"/>
+        <a:font script="Mlym" typeface="Kartika"/>
+        <a:font script="Laoo" typeface="DokChampa"/>
+        <a:font script="Sinh" typeface="Iskoola Pota"/>
+        <a:font script="Mong" typeface="Mongolian Baiti"/>
+        <a:font script="Viet" typeface="Times New Roman"/>
+        <a:font script="Uigh" typeface="Microsoft Uighur"/>
+        <a:font script="Geor" typeface="Sylfaen"/>
+        <a:font script="Armn" typeface="Arial"/>
+        <a:font script="Bugi" typeface="Leelawadee UI"/>
+        <a:font script="Bopo" typeface="Microsoft JhengHei"/>
+        <a:font script="Java" typeface="Javanese Text"/>
+        <a:font script="Lisu" typeface="Segoe UI"/>
+        <a:font script="Mymr" typeface="Myanmar Text"/>
+        <a:font script="Nkoo" typeface="Ebrima"/>
+        <a:font script="Olck" typeface="Nirmala UI"/>
+        <a:font script="Osma" typeface="Ebrima"/>
+        <a:font script="Phag" typeface="Phagspa"/>
+        <a:font script="Syrn" typeface="Estrangelo Edessa"/>
+        <a:font script="Syrj" typeface="Estrangelo Edessa"/>
+        <a:font script="Syre" typeface="Estrangelo Edessa"/>
+        <a:font script="Sora" typeface="Nirmala UI"/>
+        <a:font script="Tale" typeface="Microsoft Tai Le"/>
+        <a:font script="Talu" typeface="Microsoft New Tai Lue"/>
+        <a:font script="Tfng" typeface="Ebrima"/>
+      </a:majorFont>
+      <a:minorFont>
+        <a:latin typeface="Aptos" panose="02110004020202020204"/>
+        <a:ea typeface=""/>
+        <a:cs typeface=""/>
+        <a:font script="Jpan" typeface="游ゴシック"/>
+        <a:font script="Hang" typeface="맑은 고딕"/>
+        <a:font script="Hans" typeface="等线"/>
+        <a:font script="Hant" typeface="新細明體"/>
+        <a:font script="Arab" typeface="Arial"/>
+        <a:font script="Hebr" typeface="Arial"/>
+        <a:font script="Thai" typeface="Cordia New"/>
+        <a:font script="Ethi" typeface="Nyala"/>
+        <a:font script="Beng" typeface="Vrinda"/>
+        <a:font script="Gujr" typeface="Shruti"/>
+        <a:font script="Khmr" typeface="DaunPenh"/>
+        <a:font script="Knda" typeface="Tunga"/>
+        <a:font script="Guru" typeface="Raavi"/>
+        <a:font script="Cans" typeface="Euphemia"/>
+        <a:font script="Cher" typeface="Plantagenet Cherokee"/>
+        <a:font script="Yiii" typeface="Microsoft Yi Baiti"/>
+        <a:font script="Tibt" typeface="Microsoft Himalaya"/>
+        <a:font script="Thaa" typeface="MV Boli"/>
+        <a:font script="Deva" typeface="Mangal"/>
+        <a:font script="Telu" typeface="Gautami"/>
+        <a:font script="Taml" typeface="Latha"/>
+        <a:font script="Syrc" typeface="Estrangelo Edessa"/>
+        <a:font script="Orya" typeface="Kalinga"/>
+        <a:font script="Mlym" typeface="Kartika"/>
+        <a:font script="Laoo" typeface="DokChampa"/>
+        <a:font script="Sinh" typeface="Iskoola Pota"/>
+        <a:font script="Mong" typeface="Mongolian Baiti"/>
+        <a:font script="Viet" typeface="Arial"/>
+        <a:font script="Uigh" typeface="Microsoft Uighur"/>
+        <a:font script="Geor" typeface="Sylfaen"/>
+        <a:font script="Armn" typeface="Arial"/>
+        <a:font script="Bugi" typeface="Leelawadee UI"/>
+        <a:font script="Bopo" typeface="Microsoft JhengHei"/>
+        <a:font script="Java" typeface="Javanese Text"/>
+        <a:font script="Lisu" typeface="Segoe UI"/>
+        <a:font script="Mymr" typeface="Myanmar Text"/>
+        <a:font script="Nkoo" typeface="Ebrima"/>
+        <a:font script="Olck" typeface="Nirmala UI"/>
+        <a:font script="Osma" typeface="Ebrima"/>
+        <a:font script="Phag" typeface="Phagspa"/>
+        <a:font script="Syrn" typeface="Estrangelo Edessa"/>
+        <a:font script="Syrj" typeface="Estrangelo Edessa"/>
+        <a:font script="Syre" typeface="Estrangelo Edessa"/>
+        <a:font script="Sora" typeface="Nirmala UI"/>
+        <a:font script="Tale" typeface="Microsoft Tai Le"/>
+        <a:font script="Talu" typeface="Microsoft New Tai Lue"/>
+        <a:font script="Tfng" typeface="Ebrima"/>
+      </a:minorFont>
+    </a:fontScheme>
+    <a:fmtScheme name="Office">
+      <a:fillStyleLst>
+        <a:solidFill>
+          <a:schemeClr val="phClr"/>
+        </a:solidFill>
+        <a:gradFill rotWithShape="1">
+          <a:gsLst>
+            <a:gs pos="0">
+              <a:schemeClr val="phClr">
+                <a:lumMod val="110000"/>
+                <a:satMod val="105000"/>
+                <a:tint val="67000"/>
+              </a:schemeClr>
+            </a:gs>
+            <a:gs pos="50000">
+              <a:schemeClr val="phClr">
+                <a:lumMod val="105000"/>
+                <a:satMod val="103000"/>
+                <a:tint val="73000"/>
+              </a:schemeClr>
+            </a:gs>
+            <a:gs pos="100000">
+              <a:schemeClr val="phClr">
+                <a:lumMod val="105000"/>
+                <a:satMod val="109000"/>
+                <a:tint val="81000"/>
+              </a:schemeClr>
+            </a:gs>
+          </a:gsLst>
+          <a:lin ang="5400000" scaled="0"/>
+        </a:gradFill>
+        <a:gradFill rotWithShape="1">
+          <a:gsLst>
+            <a:gs pos="0">
+              <a:schemeClr val="phClr">
+                <a:satMod val="103000"/>
+                <a:lumMod val="102000"/>
+                <a:tint val="94000"/>
+              </a:schemeClr>
+            </a:gs>
+            <a:gs pos="50000">
+              <a:schemeClr val="phClr">
+                <a:satMod val="110000"/>
+                <a:lumMod val="100000"/>
+                <a:shade val="100000"/>
+              </a:schemeClr>
+            </a:gs>
+            <a:gs pos="100000">
+              <a:schemeClr val="phClr">
+                <a:lumMod val="99000"/>
+                <a:satMod val="120000"/>
+                <a:shade val="78000"/>
+              </a:schemeClr>
+            </a:gs>
+          </a:gsLst>
+          <a:lin ang="5400000" scaled="0"/>
+        </a:gradFill>
+      </a:fillStyleLst>
+      <a:lnStyleLst>
+        <a:ln w="12700" cap="flat" cmpd="sng" algn="ctr">
+          <a:solidFill>
+            <a:schemeClr val="phClr"/>
+          </a:solidFill>
+          <a:prstDash val="solid"/>
+          <a:miter lim="800000"/>
+        </a:ln>
+        <a:ln w="19050" cap="flat" cmpd="sng" algn="ctr">
+          <a:solidFill>
+            <a:schemeClr val="phClr"/>
+          </a:solidFill>
+          <a:prstDash val="solid"/>
+          <a:miter lim="800000"/>
+        </a:ln>
+        <a:ln w="25400" cap="flat" cmpd="sng" algn="ctr">
+          <a:solidFill>
+            <a:schemeClr val="phClr"/>
+          </a:solidFill>
+          <a:prstDash val="solid"/>
+          <a:miter lim="800000"/>
+        </a:ln>
+      </a:lnStyleLst>
+      <a:effectStyleLst>
+        <a:effectStyle>
+          <a:effectLst/>
+        </a:effectStyle>
+        <a:effectStyle>
+          <a:effectLst/>
+        </a:effectStyle>
+        <a:effectStyle>
+          <a:effectLst>
+            <a:outerShdw blurRad="57150" dist="19050" dir="5400000" algn="ctr" rotWithShape="0">
+              <a:srgbClr val="000000">
+                <a:alpha val="63000"/>
+              </a:srgbClr>
+            </a:outerShdw>
+          </a:effectLst>
+        </a:effectStyle>
+      </a:effectStyleLst>
+      <a:bgFillStyleLst>
+        <a:solidFill>
+          <a:schemeClr val="phClr"/>
+        </a:solidFill>
+        <a:solidFill>
+          <a:schemeClr val="phClr">
+            <a:tint val="95000"/>
+            <a:satMod val="170000"/>
+          </a:schemeClr>
+        </a:solidFill>
+        <a:gradFill rotWithShape="1">
+          <a:gsLst>
+            <a:gs pos="0">
+              <a:schemeClr val="phClr">
+                <a:tint val="93000"/>
+                <a:satMod val="150000"/>
+                <a:shade val="98000"/>
+                <a:lumMod val="102000"/>
+              </a:schemeClr>
+            </a:gs>
+            <a:gs pos="50000">
+              <a:schemeClr val="phClr">
+                <a:tint val="98000"/>
+                <a:satMod val="130000"/>
+                <a:shade val="90000"/>
+                <a:lumMod val="103000"/>
+              </a:schemeClr>
+            </a:gs>
+            <a:gs pos="100000">
+              <a:schemeClr val="phClr">
+                <a:shade val="63000"/>
+                <a:satMod val="120000"/>
+              </a:schemeClr>
+            </a:gs>
+          </a:gsLst>
+          <a:lin ang="5400000" scaled="0"/>
+        </a:gradFill>
+      </a:bgFillStyleLst>
+    </a:fmtScheme>
+  </a:themeElements>
+  <a:objectDefaults>
+    <a:lnDef>
+      <a:spPr/>
+      <a:bodyPr/>
+      <a:lstStyle/>
+      <a:style>
+        <a:lnRef idx="2">
+          <a:schemeClr val="accent1"/>
+        </a:lnRef>
+        <a:fillRef idx="0">
+          <a:schemeClr val="accent1"/>
+        </a:fillRef>
+        <a:effectRef idx="1">
+          <a:schemeClr val="accent1"/>
+        </a:effectRef>
+        <a:fontRef idx="minor">
+          <a:schemeClr val="tx1"/>
+        </a:fontRef>
+      </a:style>
+    </a:lnDef>
+  </a:objectDefaults>
+  <a:extraClrSchemeLst/>
+  <a:extLst>
+    <a:ext uri="{05A4C25C-085E-4340-85A3-A5531E510DB2}">
+      <thm15:themeFamily xmlns:thm15="http://schemas.microsoft.com/office/thememl/2012/main" name="Office Theme" id="{2E142A2C-CD16-42D6-873A-C26D2A0506FA}" vid="{1BDDFF52-6CD6-40A5-AB3C-68EB2F1E4D0A}"/>
+    </a:ext>
+  </a:extLst>
+</a:theme>
 </file>
</xml_diff>